<commit_message>
architect-ppt: switch to 16:9 and add per-page builders
- Canvas now 16:9 (13.333 x 7.5)
- pageColumns builder: 과제 배경(3단)/필요성(2단)/범위(3단), each column
  holds 2 content items with a matching image; blank box when no image
- pageOverview builder: 과제 개요 2단 — left info table
  (과제명/과제목표/참여인력/일정), right overall architecture (blank until given)
- itemColumn helper for text+image item stacks
- Document per-page rules and the web-image sourcing/blank-fallback rule
</commit_message>
<xml_diff>
--- a/.claude/skills/architect-ppt/assets/architect_template.pptx
+++ b/.claude/skills/architect-ppt/assets/architect_template.pptx
@@ -8,12 +8,13 @@
     <p:sldId id="256" r:id="rId2"/>
     <p:sldId id="257" r:id="rId3"/>
     <p:sldId id="258" r:id="rId4"/>
+    <p:sldId id="259" r:id="rId5"/>
   </p:sldIdLst>
   <p:notesMasterIdLst>
-    <p:notesMasterId r:id="rId5"/>
+    <p:notesMasterId r:id="rId6"/>
   </p:notesMasterIdLst>
-  <p:sldSz cx="9144000" cy="6858000"/>
-  <p:notesSz cx="6858000" cy="9144000"/>
+  <p:sldSz cx="12191695" cy="6858000"/>
+  <p:notesSz cx="6858000" cy="12191695"/>
   <p:defaultTextStyle>
     <a:lvl1pPr marL="0" algn="l" defTabSz="914400" rtl="0" eaLnBrk="1" latinLnBrk="0" hangingPunct="1">
       <a:defRPr sz="1800" kern="1200">
@@ -722,6 +723,94 @@
 </p:notes>
 </file>
 
+<file path=ppt/notesSlides/notesSlide4.xml><?xml version="1.0" encoding="utf-8"?>
+<p:notes xmlns:a="http://schemas.openxmlformats.org/drawingml/2006/main" xmlns:r="http://schemas.openxmlformats.org/officeDocument/2006/relationships" xmlns:p="http://schemas.openxmlformats.org/presentationml/2006/main">
+  <p:cSld>
+    <p:spTree>
+      <p:nvGrpSpPr>
+        <p:cNvPr id="1" name=""/>
+        <p:cNvGrpSpPr/>
+        <p:nvPr/>
+      </p:nvGrpSpPr>
+      <p:grpSpPr>
+        <a:xfrm>
+          <a:off x="0" y="0"/>
+          <a:ext cx="0" cy="0"/>
+          <a:chOff x="0" y="0"/>
+          <a:chExt cx="0" cy="0"/>
+        </a:xfrm>
+      </p:grpSpPr>
+      <p:sp>
+        <p:nvSpPr>
+          <p:cNvPr id="2" name="Slide Image Placeholder 1"/>
+          <p:cNvSpPr>
+            <a:spLocks noGrp="1" noRot="1" noChangeAspect="1"/>
+          </p:cNvSpPr>
+          <p:nvPr>
+            <p:ph type="sldImg"/>
+          </p:nvPr>
+        </p:nvSpPr>
+        <p:spPr/>
+      </p:sp>
+      <p:sp>
+        <p:nvSpPr>
+          <p:cNvPr id="3" name="Notes Placeholder 2"/>
+          <p:cNvSpPr>
+            <a:spLocks noGrp="1"/>
+          </p:cNvSpPr>
+          <p:nvPr>
+            <p:ph type="body" idx="1"/>
+          </p:nvPr>
+        </p:nvSpPr>
+        <p:spPr/>
+        <p:txBody>
+          <a:bodyPr/>
+          <a:lstStyle/>
+          <a:p>
+            <a:r>
+              <a:rPr lang="en-US" dirty="0"/>
+              <a:t/>
+            </a:r>
+            <a:endParaRPr lang="en-US" dirty="0"/>
+          </a:p>
+        </p:txBody>
+      </p:sp>
+      <p:sp>
+        <p:nvSpPr>
+          <p:cNvPr id="4" name="Slide Number Placeholder 3"/>
+          <p:cNvSpPr>
+            <a:spLocks noGrp="1"/>
+          </p:cNvSpPr>
+          <p:nvPr>
+            <p:ph type="sldNum" sz="quarter" idx="10"/>
+          </p:nvPr>
+        </p:nvSpPr>
+        <p:spPr/>
+        <p:txBody>
+          <a:bodyPr/>
+          <a:lstStyle/>
+          <a:p>
+            <a:fld id="{F7021451-1387-4CA6-816F-3879F97B5CBC}" type="slidenum">
+              <a:rPr lang="en-US"/>
+              <a:t>4</a:t>
+            </a:fld>
+            <a:endParaRPr lang="en-US"/>
+          </a:p>
+        </p:txBody>
+      </p:sp>
+    </p:spTree>
+    <p:extLst>
+      <p:ext uri="{BB962C8B-B14F-4D97-AF65-F5344CB8AC3E}">
+        <p14:creationId xmlns:p14="http://schemas.microsoft.com/office/powerpoint/2010/main" val="1024086991"/>
+      </p:ext>
+    </p:extLst>
+  </p:cSld>
+  <p:clrMapOvr>
+    <a:masterClrMapping/>
+  </p:clrMapOvr>
+</p:notes>
+</file>
+
 <file path=ppt/slideLayouts/slideLayout1.xml><?xml version="1.0" encoding="utf-8"?>
 <p:sldLayout xmlns:a="http://schemas.openxmlformats.org/drawingml/2006/main" xmlns:r="http://schemas.openxmlformats.org/officeDocument/2006/relationships" xmlns:p="http://schemas.openxmlformats.org/presentationml/2006/main" preserve="1">
   <p:cSld name="DEFAULT">
@@ -1055,7 +1144,7 @@
         <p:spPr>
           <a:xfrm>
             <a:off x="0" y="0"/>
-            <a:ext cx="9144000" cy="914400"/>
+            <a:ext cx="12191695" cy="914400"/>
           </a:xfrm>
           <a:prstGeom prst="rect">
             <a:avLst/>
@@ -1113,7 +1202,7 @@
         </p:nvSpPr>
         <p:spPr>
           <a:xfrm>
-            <a:off x="4160520" y="320040"/>
+            <a:off x="7208215" y="320040"/>
             <a:ext cx="786384" cy="274320"/>
           </a:xfrm>
           <a:prstGeom prst="rect">
@@ -1138,7 +1227,7 @@
         </p:nvSpPr>
         <p:spPr>
           <a:xfrm>
-            <a:off x="4160520" y="320040"/>
+            <a:off x="7208215" y="320040"/>
             <a:ext cx="786384" cy="274320"/>
           </a:xfrm>
           <a:prstGeom prst="rect">
@@ -1177,7 +1266,7 @@
         </p:nvSpPr>
         <p:spPr>
           <a:xfrm>
-            <a:off x="4960620" y="338328"/>
+            <a:off x="8008315" y="338328"/>
             <a:ext cx="155448" cy="237744"/>
           </a:xfrm>
           <a:prstGeom prst="chevron">
@@ -1197,7 +1286,7 @@
         </p:nvSpPr>
         <p:spPr>
           <a:xfrm>
-            <a:off x="5129784" y="320040"/>
+            <a:off x="8177479" y="320040"/>
             <a:ext cx="786384" cy="274320"/>
           </a:xfrm>
           <a:prstGeom prst="rect">
@@ -1222,7 +1311,7 @@
         </p:nvSpPr>
         <p:spPr>
           <a:xfrm>
-            <a:off x="5129784" y="320040"/>
+            <a:off x="8177479" y="320040"/>
             <a:ext cx="786384" cy="274320"/>
           </a:xfrm>
           <a:prstGeom prst="rect">
@@ -1261,7 +1350,7 @@
         </p:nvSpPr>
         <p:spPr>
           <a:xfrm>
-            <a:off x="5929884" y="338328"/>
+            <a:off x="8977579" y="338328"/>
             <a:ext cx="155448" cy="237744"/>
           </a:xfrm>
           <a:prstGeom prst="chevron">
@@ -1281,7 +1370,7 @@
         </p:nvSpPr>
         <p:spPr>
           <a:xfrm>
-            <a:off x="6099048" y="320040"/>
+            <a:off x="9146743" y="320040"/>
             <a:ext cx="786384" cy="274320"/>
           </a:xfrm>
           <a:prstGeom prst="rect">
@@ -1306,7 +1395,7 @@
         </p:nvSpPr>
         <p:spPr>
           <a:xfrm>
-            <a:off x="6099048" y="320040"/>
+            <a:off x="9146743" y="320040"/>
             <a:ext cx="786384" cy="274320"/>
           </a:xfrm>
           <a:prstGeom prst="rect">
@@ -1345,7 +1434,7 @@
         </p:nvSpPr>
         <p:spPr>
           <a:xfrm>
-            <a:off x="6899148" y="338328"/>
+            <a:off x="9946843" y="338328"/>
             <a:ext cx="155448" cy="237744"/>
           </a:xfrm>
           <a:prstGeom prst="chevron">
@@ -1365,7 +1454,7 @@
         </p:nvSpPr>
         <p:spPr>
           <a:xfrm>
-            <a:off x="7068312" y="320040"/>
+            <a:off x="10116007" y="320040"/>
             <a:ext cx="786384" cy="274320"/>
           </a:xfrm>
           <a:prstGeom prst="rect">
@@ -1390,7 +1479,7 @@
         </p:nvSpPr>
         <p:spPr>
           <a:xfrm>
-            <a:off x="7068312" y="320040"/>
+            <a:off x="10116007" y="320040"/>
             <a:ext cx="786384" cy="274320"/>
           </a:xfrm>
           <a:prstGeom prst="rect">
@@ -1429,7 +1518,7 @@
         </p:nvSpPr>
         <p:spPr>
           <a:xfrm>
-            <a:off x="7868412" y="338328"/>
+            <a:off x="10916107" y="338328"/>
             <a:ext cx="155448" cy="237744"/>
           </a:xfrm>
           <a:prstGeom prst="chevron">
@@ -1449,7 +1538,7 @@
         </p:nvSpPr>
         <p:spPr>
           <a:xfrm>
-            <a:off x="8037576" y="320040"/>
+            <a:off x="11085271" y="320040"/>
             <a:ext cx="786384" cy="274320"/>
           </a:xfrm>
           <a:prstGeom prst="rect">
@@ -1474,7 +1563,7 @@
         </p:nvSpPr>
         <p:spPr>
           <a:xfrm>
-            <a:off x="8037576" y="320040"/>
+            <a:off x="11085271" y="320040"/>
             <a:ext cx="786384" cy="274320"/>
           </a:xfrm>
           <a:prstGeom prst="rect">
@@ -1513,7 +1602,7 @@
         </p:nvSpPr>
         <p:spPr>
           <a:xfrm>
-            <a:off x="7680960" y="6492240"/>
+            <a:off x="10728655" y="6492240"/>
             <a:ext cx="1280160" cy="256032"/>
           </a:xfrm>
           <a:prstGeom prst="rect">
@@ -1560,17 +1649,17 @@
         </p:nvGraphicFramePr>
         <p:xfrm>
           <a:off x="320040" y="1078992"/>
-          <a:ext cx="4160520" cy="5367528"/>
+          <a:ext cx="5675224" cy="5367528"/>
         </p:xfrm>
         <a:graphic>
           <a:graphicData uri="http://schemas.openxmlformats.org/drawingml/2006/table">
             <a:tbl>
               <a:tblPr/>
               <a:tblGrid>
-                <a:gridCol w="1280160"/>
-                <a:gridCol w="2880360"/>
+                <a:gridCol w="1554480"/>
+                <a:gridCol w="4120744"/>
               </a:tblGrid>
-              <a:tr h="766790">
+              <a:tr h="1341882">
                 <a:tc>
                   <a:txBody>
                     <a:bodyPr/>
@@ -1735,7 +1824,7 @@
                   </a:tcPr>
                 </a:tc>
               </a:tr>
-              <a:tr h="766790">
+              <a:tr h="1341882">
                 <a:tc>
                   <a:txBody>
                     <a:bodyPr/>
@@ -1753,7 +1842,7 @@
                           <a:ea typeface="Malgun Gothic" pitchFamily="34" charset="-122"/>
                           <a:cs typeface="Malgun Gothic" pitchFamily="34" charset="-120"/>
                         </a:rPr>
-                        <a:t>과제 개요</a:t>
+                        <a:t>과제 목표</a:t>
                       </a:r>
                       <a:endParaRPr lang="en-US" sz="1100" dirty="0">
                         <a:latin typeface="Malgun Gothic" charset="0"/>
@@ -1825,7 +1914,7 @@
                           <a:ea typeface="Malgun Gothic" pitchFamily="34" charset="-122"/>
                           <a:cs typeface="Malgun Gothic" pitchFamily="34" charset="-120"/>
                         </a:rPr>
-                        <a:t>개요 문장 1</a:t>
+                        <a:t>목표 문장 1</a:t>
                       </a:r>
                       <a:endParaRPr lang="en-US" sz="1100" dirty="0">
                         <a:latin typeface="Malgun Gothic" charset="0"/>
@@ -1850,7 +1939,7 @@
                           <a:ea typeface="Malgun Gothic" pitchFamily="34" charset="-122"/>
                           <a:cs typeface="Malgun Gothic" pitchFamily="34" charset="-120"/>
                         </a:rPr>
-                        <a:t>개요 문장 2</a:t>
+                        <a:t>목표 문장 2</a:t>
                       </a:r>
                       <a:endParaRPr lang="en-US" sz="1100" dirty="0">
                         <a:latin typeface="Malgun Gothic" charset="0"/>
@@ -1902,7 +1991,7 @@
                   </a:tcPr>
                 </a:tc>
               </a:tr>
-              <a:tr h="766790">
+              <a:tr h="1341882">
                 <a:tc>
                   <a:txBody>
                     <a:bodyPr/>
@@ -2069,7 +2158,7 @@
                   </a:tcPr>
                 </a:tc>
               </a:tr>
-              <a:tr h="766790">
+              <a:tr h="1341882">
                 <a:tc>
                   <a:txBody>
                     <a:bodyPr/>
@@ -2087,7 +2176,7 @@
                           <a:ea typeface="Malgun Gothic" pitchFamily="34" charset="-122"/>
                           <a:cs typeface="Malgun Gothic" pitchFamily="34" charset="-120"/>
                         </a:rPr>
-                        <a:t>개발 기간</a:t>
+                        <a:t>일정</a:t>
                       </a:r>
                       <a:endParaRPr lang="en-US" sz="1100" dirty="0">
                         <a:latin typeface="Malgun Gothic" charset="0"/>
@@ -2211,532 +2300,6 @@
                   </a:tcPr>
                 </a:tc>
               </a:tr>
-              <a:tr h="766790">
-                <a:tc>
-                  <a:txBody>
-                    <a:bodyPr/>
-                    <a:lstStyle/>
-                    <a:p>
-                      <a:pPr algn="ctr" indent="0" marL="0">
-                        <a:buNone/>
-                      </a:pPr>
-                      <a:r>
-                        <a:rPr lang="en-US" sz="1100" b="1" dirty="0">
-                          <a:solidFill>
-                            <a:srgbClr val="FFFFFF"/>
-                          </a:solidFill>
-                          <a:latin typeface="Malgun Gothic" pitchFamily="34" charset="0"/>
-                          <a:ea typeface="Malgun Gothic" pitchFamily="34" charset="-122"/>
-                          <a:cs typeface="Malgun Gothic" pitchFamily="34" charset="-120"/>
-                        </a:rPr>
-                        <a:t>개발 환경</a:t>
-                      </a:r>
-                      <a:endParaRPr lang="en-US" sz="1100" dirty="0">
-                        <a:latin typeface="Malgun Gothic" charset="0"/>
-                        <a:ea typeface="Malgun Gothic" charset="0"/>
-                        <a:cs typeface="Malgun Gothic" charset="0"/>
-                      </a:endParaRPr>
-                    </a:p>
-                  </a:txBody>
-                  <a:tcPr marL="91440" marR="91440" marT="45720" marB="45720" anchor="ctr">
-                    <a:lnL w="9525" cap="flat" cmpd="sng" algn="ctr">
-                      <a:solidFill>
-                        <a:srgbClr val="A6A6A6"/>
-                      </a:solidFill>
-                      <a:prstDash val="solid"/>
-                      <a:round/>
-                      <a:headEnd type="none" w="med" len="med"/>
-                      <a:tailEnd type="none" w="med" len="med"/>
-                    </a:lnL>
-                    <a:lnR w="9525" cap="flat" cmpd="sng" algn="ctr">
-                      <a:solidFill>
-                        <a:srgbClr val="A6A6A6"/>
-                      </a:solidFill>
-                      <a:prstDash val="solid"/>
-                      <a:round/>
-                      <a:headEnd type="none" w="med" len="med"/>
-                      <a:tailEnd type="none" w="med" len="med"/>
-                    </a:lnR>
-                    <a:lnT w="9525" cap="flat" cmpd="sng" algn="ctr">
-                      <a:solidFill>
-                        <a:srgbClr val="A6A6A6"/>
-                      </a:solidFill>
-                      <a:prstDash val="solid"/>
-                      <a:round/>
-                      <a:headEnd type="none" w="med" len="med"/>
-                      <a:tailEnd type="none" w="med" len="med"/>
-                    </a:lnT>
-                    <a:lnB w="9525" cap="flat" cmpd="sng" algn="ctr">
-                      <a:solidFill>
-                        <a:srgbClr val="A6A6A6"/>
-                      </a:solidFill>
-                      <a:prstDash val="solid"/>
-                      <a:round/>
-                      <a:headEnd type="none" w="med" len="med"/>
-                      <a:tailEnd type="none" w="med" len="med"/>
-                    </a:lnB>
-                    <a:solidFill>
-                      <a:srgbClr val="1F3864"/>
-                    </a:solidFill>
-                  </a:tcPr>
-                </a:tc>
-                <a:tc>
-                  <a:txBody>
-                    <a:bodyPr/>
-                    <a:lstStyle/>
-                    <a:p>
-                      <a:pPr algn="l" marL="152400" indent="-152400">
-                        <a:spcAft>
-                          <a:spcPts val="200"/>
-                        </a:spcAft>
-                        <a:buSzPct val="100000"/>
-                        <a:buChar char="•"/>
-                      </a:pPr>
-                      <a:r>
-                        <a:rPr lang="en-US" sz="1100" dirty="0">
-                          <a:solidFill>
-                            <a:srgbClr val="262626"/>
-                          </a:solidFill>
-                          <a:latin typeface="Malgun Gothic" pitchFamily="34" charset="0"/>
-                          <a:ea typeface="Malgun Gothic" pitchFamily="34" charset="-122"/>
-                          <a:cs typeface="Malgun Gothic" pitchFamily="34" charset="-120"/>
-                        </a:rPr>
-                        <a:t>항목 1</a:t>
-                      </a:r>
-                      <a:endParaRPr lang="en-US" sz="1100" dirty="0">
-                        <a:latin typeface="Malgun Gothic" charset="0"/>
-                        <a:ea typeface="Malgun Gothic" charset="0"/>
-                        <a:cs typeface="Malgun Gothic" charset="0"/>
-                      </a:endParaRPr>
-                    </a:p>
-                    <a:p>
-                      <a:pPr algn="l" marL="152400" indent="-152400">
-                        <a:spcAft>
-                          <a:spcPts val="200"/>
-                        </a:spcAft>
-                        <a:buSzPct val="100000"/>
-                        <a:buChar char="•"/>
-                      </a:pPr>
-                      <a:r>
-                        <a:rPr lang="en-US" sz="1100" dirty="0">
-                          <a:solidFill>
-                            <a:srgbClr val="262626"/>
-                          </a:solidFill>
-                          <a:latin typeface="Malgun Gothic" pitchFamily="34" charset="0"/>
-                          <a:ea typeface="Malgun Gothic" pitchFamily="34" charset="-122"/>
-                          <a:cs typeface="Malgun Gothic" pitchFamily="34" charset="-120"/>
-                        </a:rPr>
-                        <a:t>항목 2</a:t>
-                      </a:r>
-                      <a:endParaRPr lang="en-US" sz="1100" dirty="0">
-                        <a:latin typeface="Malgun Gothic" charset="0"/>
-                        <a:ea typeface="Malgun Gothic" charset="0"/>
-                        <a:cs typeface="Malgun Gothic" charset="0"/>
-                      </a:endParaRPr>
-                    </a:p>
-                    <a:p>
-                      <a:pPr algn="l" marL="152400" indent="-152400">
-                        <a:spcAft>
-                          <a:spcPts val="200"/>
-                        </a:spcAft>
-                        <a:buSzPct val="100000"/>
-                        <a:buChar char="•"/>
-                      </a:pPr>
-                      <a:r>
-                        <a:rPr lang="en-US" sz="1100" dirty="0">
-                          <a:solidFill>
-                            <a:srgbClr val="262626"/>
-                          </a:solidFill>
-                          <a:latin typeface="Malgun Gothic" pitchFamily="34" charset="0"/>
-                          <a:ea typeface="Malgun Gothic" pitchFamily="34" charset="-122"/>
-                          <a:cs typeface="Malgun Gothic" pitchFamily="34" charset="-120"/>
-                        </a:rPr>
-                        <a:t>항목 3</a:t>
-                      </a:r>
-                      <a:endParaRPr lang="en-US" sz="1100" dirty="0">
-                        <a:latin typeface="Malgun Gothic" charset="0"/>
-                        <a:ea typeface="Malgun Gothic" charset="0"/>
-                        <a:cs typeface="Malgun Gothic" charset="0"/>
-                      </a:endParaRPr>
-                    </a:p>
-                  </a:txBody>
-                  <a:tcPr marL="76200" marR="76200" marT="38100" marB="38100" anchor="ctr">
-                    <a:lnL w="9525" cap="flat" cmpd="sng" algn="ctr">
-                      <a:solidFill>
-                        <a:srgbClr val="A6A6A6"/>
-                      </a:solidFill>
-                      <a:prstDash val="solid"/>
-                      <a:round/>
-                      <a:headEnd type="none" w="med" len="med"/>
-                      <a:tailEnd type="none" w="med" len="med"/>
-                    </a:lnL>
-                    <a:lnR w="9525" cap="flat" cmpd="sng" algn="ctr">
-                      <a:solidFill>
-                        <a:srgbClr val="A6A6A6"/>
-                      </a:solidFill>
-                      <a:prstDash val="solid"/>
-                      <a:round/>
-                      <a:headEnd type="none" w="med" len="med"/>
-                      <a:tailEnd type="none" w="med" len="med"/>
-                    </a:lnR>
-                    <a:lnT w="9525" cap="flat" cmpd="sng" algn="ctr">
-                      <a:solidFill>
-                        <a:srgbClr val="A6A6A6"/>
-                      </a:solidFill>
-                      <a:prstDash val="solid"/>
-                      <a:round/>
-                      <a:headEnd type="none" w="med" len="med"/>
-                      <a:tailEnd type="none" w="med" len="med"/>
-                    </a:lnT>
-                    <a:lnB w="9525" cap="flat" cmpd="sng" algn="ctr">
-                      <a:solidFill>
-                        <a:srgbClr val="A6A6A6"/>
-                      </a:solidFill>
-                      <a:prstDash val="solid"/>
-                      <a:round/>
-                      <a:headEnd type="none" w="med" len="med"/>
-                      <a:tailEnd type="none" w="med" len="med"/>
-                    </a:lnB>
-                    <a:solidFill>
-                      <a:srgbClr val="FFFFFF"/>
-                    </a:solidFill>
-                  </a:tcPr>
-                </a:tc>
-              </a:tr>
-              <a:tr h="766790">
-                <a:tc>
-                  <a:txBody>
-                    <a:bodyPr/>
-                    <a:lstStyle/>
-                    <a:p>
-                      <a:pPr algn="ctr" indent="0" marL="0">
-                        <a:buNone/>
-                      </a:pPr>
-                      <a:r>
-                        <a:rPr lang="en-US" sz="1100" b="1" dirty="0">
-                          <a:solidFill>
-                            <a:srgbClr val="FFFFFF"/>
-                          </a:solidFill>
-                          <a:latin typeface="Malgun Gothic" pitchFamily="34" charset="0"/>
-                          <a:ea typeface="Malgun Gothic" pitchFamily="34" charset="-122"/>
-                          <a:cs typeface="Malgun Gothic" pitchFamily="34" charset="-120"/>
-                        </a:rPr>
-                        <a:t>타겟 시스템 / 장치</a:t>
-                      </a:r>
-                      <a:endParaRPr lang="en-US" sz="1100" dirty="0">
-                        <a:latin typeface="Malgun Gothic" charset="0"/>
-                        <a:ea typeface="Malgun Gothic" charset="0"/>
-                        <a:cs typeface="Malgun Gothic" charset="0"/>
-                      </a:endParaRPr>
-                    </a:p>
-                  </a:txBody>
-                  <a:tcPr marL="91440" marR="91440" marT="45720" marB="45720" anchor="ctr">
-                    <a:lnL w="9525" cap="flat" cmpd="sng" algn="ctr">
-                      <a:solidFill>
-                        <a:srgbClr val="A6A6A6"/>
-                      </a:solidFill>
-                      <a:prstDash val="solid"/>
-                      <a:round/>
-                      <a:headEnd type="none" w="med" len="med"/>
-                      <a:tailEnd type="none" w="med" len="med"/>
-                    </a:lnL>
-                    <a:lnR w="9525" cap="flat" cmpd="sng" algn="ctr">
-                      <a:solidFill>
-                        <a:srgbClr val="A6A6A6"/>
-                      </a:solidFill>
-                      <a:prstDash val="solid"/>
-                      <a:round/>
-                      <a:headEnd type="none" w="med" len="med"/>
-                      <a:tailEnd type="none" w="med" len="med"/>
-                    </a:lnR>
-                    <a:lnT w="9525" cap="flat" cmpd="sng" algn="ctr">
-                      <a:solidFill>
-                        <a:srgbClr val="A6A6A6"/>
-                      </a:solidFill>
-                      <a:prstDash val="solid"/>
-                      <a:round/>
-                      <a:headEnd type="none" w="med" len="med"/>
-                      <a:tailEnd type="none" w="med" len="med"/>
-                    </a:lnT>
-                    <a:lnB w="9525" cap="flat" cmpd="sng" algn="ctr">
-                      <a:solidFill>
-                        <a:srgbClr val="A6A6A6"/>
-                      </a:solidFill>
-                      <a:prstDash val="solid"/>
-                      <a:round/>
-                      <a:headEnd type="none" w="med" len="med"/>
-                      <a:tailEnd type="none" w="med" len="med"/>
-                    </a:lnB>
-                    <a:solidFill>
-                      <a:srgbClr val="1F3864"/>
-                    </a:solidFill>
-                  </a:tcPr>
-                </a:tc>
-                <a:tc>
-                  <a:txBody>
-                    <a:bodyPr/>
-                    <a:lstStyle/>
-                    <a:p>
-                      <a:pPr algn="l" marL="152400" indent="-152400">
-                        <a:spcAft>
-                          <a:spcPts val="200"/>
-                        </a:spcAft>
-                        <a:buSzPct val="100000"/>
-                        <a:buChar char="•"/>
-                      </a:pPr>
-                      <a:r>
-                        <a:rPr lang="en-US" sz="1100" b="1" dirty="0">
-                          <a:solidFill>
-                            <a:srgbClr val="1F3864"/>
-                          </a:solidFill>
-                          <a:latin typeface="Malgun Gothic" pitchFamily="34" charset="0"/>
-                          <a:ea typeface="Malgun Gothic" pitchFamily="34" charset="-122"/>
-                          <a:cs typeface="Malgun Gothic" pitchFamily="34" charset="-120"/>
-                        </a:rPr>
-                        <a:t>#1. ...</a:t>
-                      </a:r>
-                      <a:endParaRPr lang="en-US" sz="1100" dirty="0">
-                        <a:latin typeface="Malgun Gothic" charset="0"/>
-                        <a:ea typeface="Malgun Gothic" charset="0"/>
-                        <a:cs typeface="Malgun Gothic" charset="0"/>
-                      </a:endParaRPr>
-                    </a:p>
-                    <a:p>
-                      <a:pPr algn="l" marL="152400" indent="-152400">
-                        <a:spcAft>
-                          <a:spcPts val="200"/>
-                        </a:spcAft>
-                        <a:buSzPct val="100000"/>
-                        <a:buChar char="•"/>
-                      </a:pPr>
-                      <a:r>
-                        <a:rPr lang="en-US" sz="1100" b="1" dirty="0">
-                          <a:solidFill>
-                            <a:srgbClr val="1F3864"/>
-                          </a:solidFill>
-                          <a:latin typeface="Malgun Gothic" pitchFamily="34" charset="0"/>
-                          <a:ea typeface="Malgun Gothic" pitchFamily="34" charset="-122"/>
-                          <a:cs typeface="Malgun Gothic" pitchFamily="34" charset="-120"/>
-                        </a:rPr>
-                        <a:t>#2. ...</a:t>
-                      </a:r>
-                      <a:endParaRPr lang="en-US" sz="1100" dirty="0">
-                        <a:latin typeface="Malgun Gothic" charset="0"/>
-                        <a:ea typeface="Malgun Gothic" charset="0"/>
-                        <a:cs typeface="Malgun Gothic" charset="0"/>
-                      </a:endParaRPr>
-                    </a:p>
-                  </a:txBody>
-                  <a:tcPr marL="76200" marR="76200" marT="38100" marB="38100" anchor="ctr">
-                    <a:lnL w="9525" cap="flat" cmpd="sng" algn="ctr">
-                      <a:solidFill>
-                        <a:srgbClr val="A6A6A6"/>
-                      </a:solidFill>
-                      <a:prstDash val="solid"/>
-                      <a:round/>
-                      <a:headEnd type="none" w="med" len="med"/>
-                      <a:tailEnd type="none" w="med" len="med"/>
-                    </a:lnL>
-                    <a:lnR w="9525" cap="flat" cmpd="sng" algn="ctr">
-                      <a:solidFill>
-                        <a:srgbClr val="A6A6A6"/>
-                      </a:solidFill>
-                      <a:prstDash val="solid"/>
-                      <a:round/>
-                      <a:headEnd type="none" w="med" len="med"/>
-                      <a:tailEnd type="none" w="med" len="med"/>
-                    </a:lnR>
-                    <a:lnT w="9525" cap="flat" cmpd="sng" algn="ctr">
-                      <a:solidFill>
-                        <a:srgbClr val="A6A6A6"/>
-                      </a:solidFill>
-                      <a:prstDash val="solid"/>
-                      <a:round/>
-                      <a:headEnd type="none" w="med" len="med"/>
-                      <a:tailEnd type="none" w="med" len="med"/>
-                    </a:lnT>
-                    <a:lnB w="9525" cap="flat" cmpd="sng" algn="ctr">
-                      <a:solidFill>
-                        <a:srgbClr val="A6A6A6"/>
-                      </a:solidFill>
-                      <a:prstDash val="solid"/>
-                      <a:round/>
-                      <a:headEnd type="none" w="med" len="med"/>
-                      <a:tailEnd type="none" w="med" len="med"/>
-                    </a:lnB>
-                    <a:solidFill>
-                      <a:srgbClr val="FFFFFF"/>
-                    </a:solidFill>
-                  </a:tcPr>
-                </a:tc>
-              </a:tr>
-              <a:tr h="766790">
-                <a:tc>
-                  <a:txBody>
-                    <a:bodyPr/>
-                    <a:lstStyle/>
-                    <a:p>
-                      <a:pPr algn="ctr" indent="0" marL="0">
-                        <a:buNone/>
-                      </a:pPr>
-                      <a:r>
-                        <a:rPr lang="en-US" sz="1100" b="1" dirty="0">
-                          <a:solidFill>
-                            <a:srgbClr val="FFFFFF"/>
-                          </a:solidFill>
-                          <a:latin typeface="Malgun Gothic" pitchFamily="34" charset="0"/>
-                          <a:ea typeface="Malgun Gothic" pitchFamily="34" charset="-122"/>
-                          <a:cs typeface="Malgun Gothic" pitchFamily="34" charset="-120"/>
-                        </a:rPr>
-                        <a:t>주요 성과</a:t>
-                      </a:r>
-                      <a:endParaRPr lang="en-US" sz="1100" dirty="0">
-                        <a:latin typeface="Malgun Gothic" charset="0"/>
-                        <a:ea typeface="Malgun Gothic" charset="0"/>
-                        <a:cs typeface="Malgun Gothic" charset="0"/>
-                      </a:endParaRPr>
-                    </a:p>
-                  </a:txBody>
-                  <a:tcPr marL="91440" marR="91440" marT="45720" marB="45720" anchor="ctr">
-                    <a:lnL w="9525" cap="flat" cmpd="sng" algn="ctr">
-                      <a:solidFill>
-                        <a:srgbClr val="A6A6A6"/>
-                      </a:solidFill>
-                      <a:prstDash val="solid"/>
-                      <a:round/>
-                      <a:headEnd type="none" w="med" len="med"/>
-                      <a:tailEnd type="none" w="med" len="med"/>
-                    </a:lnL>
-                    <a:lnR w="9525" cap="flat" cmpd="sng" algn="ctr">
-                      <a:solidFill>
-                        <a:srgbClr val="A6A6A6"/>
-                      </a:solidFill>
-                      <a:prstDash val="solid"/>
-                      <a:round/>
-                      <a:headEnd type="none" w="med" len="med"/>
-                      <a:tailEnd type="none" w="med" len="med"/>
-                    </a:lnR>
-                    <a:lnT w="9525" cap="flat" cmpd="sng" algn="ctr">
-                      <a:solidFill>
-                        <a:srgbClr val="A6A6A6"/>
-                      </a:solidFill>
-                      <a:prstDash val="solid"/>
-                      <a:round/>
-                      <a:headEnd type="none" w="med" len="med"/>
-                      <a:tailEnd type="none" w="med" len="med"/>
-                    </a:lnT>
-                    <a:lnB w="9525" cap="flat" cmpd="sng" algn="ctr">
-                      <a:solidFill>
-                        <a:srgbClr val="A6A6A6"/>
-                      </a:solidFill>
-                      <a:prstDash val="solid"/>
-                      <a:round/>
-                      <a:headEnd type="none" w="med" len="med"/>
-                      <a:tailEnd type="none" w="med" len="med"/>
-                    </a:lnB>
-                    <a:solidFill>
-                      <a:srgbClr val="1F3864"/>
-                    </a:solidFill>
-                  </a:tcPr>
-                </a:tc>
-                <a:tc>
-                  <a:txBody>
-                    <a:bodyPr/>
-                    <a:lstStyle/>
-                    <a:p>
-                      <a:pPr algn="l" marL="152400" indent="-152400">
-                        <a:spcAft>
-                          <a:spcPts val="200"/>
-                        </a:spcAft>
-                        <a:buSzPct val="100000"/>
-                        <a:buChar char="•"/>
-                      </a:pPr>
-                      <a:r>
-                        <a:rPr lang="en-US" sz="1100" dirty="0">
-                          <a:solidFill>
-                            <a:srgbClr val="262626"/>
-                          </a:solidFill>
-                          <a:latin typeface="Malgun Gothic" pitchFamily="34" charset="0"/>
-                          <a:ea typeface="Malgun Gothic" pitchFamily="34" charset="-122"/>
-                          <a:cs typeface="Malgun Gothic" pitchFamily="34" charset="-120"/>
-                        </a:rPr>
-                        <a:t>성과 1</a:t>
-                      </a:r>
-                      <a:endParaRPr lang="en-US" sz="1100" dirty="0">
-                        <a:latin typeface="Malgun Gothic" charset="0"/>
-                        <a:ea typeface="Malgun Gothic" charset="0"/>
-                        <a:cs typeface="Malgun Gothic" charset="0"/>
-                      </a:endParaRPr>
-                    </a:p>
-                    <a:p>
-                      <a:pPr algn="l" marL="152400" indent="-152400">
-                        <a:spcAft>
-                          <a:spcPts val="200"/>
-                        </a:spcAft>
-                        <a:buSzPct val="100000"/>
-                        <a:buChar char="•"/>
-                      </a:pPr>
-                      <a:r>
-                        <a:rPr lang="en-US" sz="1100" dirty="0">
-                          <a:solidFill>
-                            <a:srgbClr val="262626"/>
-                          </a:solidFill>
-                          <a:latin typeface="Malgun Gothic" pitchFamily="34" charset="0"/>
-                          <a:ea typeface="Malgun Gothic" pitchFamily="34" charset="-122"/>
-                          <a:cs typeface="Malgun Gothic" pitchFamily="34" charset="-120"/>
-                        </a:rPr>
-                        <a:t>성과 2</a:t>
-                      </a:r>
-                      <a:endParaRPr lang="en-US" sz="1100" dirty="0">
-                        <a:latin typeface="Malgun Gothic" charset="0"/>
-                        <a:ea typeface="Malgun Gothic" charset="0"/>
-                        <a:cs typeface="Malgun Gothic" charset="0"/>
-                      </a:endParaRPr>
-                    </a:p>
-                  </a:txBody>
-                  <a:tcPr marL="76200" marR="76200" marT="38100" marB="38100" anchor="ctr">
-                    <a:lnL w="9525" cap="flat" cmpd="sng" algn="ctr">
-                      <a:solidFill>
-                        <a:srgbClr val="A6A6A6"/>
-                      </a:solidFill>
-                      <a:prstDash val="solid"/>
-                      <a:round/>
-                      <a:headEnd type="none" w="med" len="med"/>
-                      <a:tailEnd type="none" w="med" len="med"/>
-                    </a:lnL>
-                    <a:lnR w="9525" cap="flat" cmpd="sng" algn="ctr">
-                      <a:solidFill>
-                        <a:srgbClr val="A6A6A6"/>
-                      </a:solidFill>
-                      <a:prstDash val="solid"/>
-                      <a:round/>
-                      <a:headEnd type="none" w="med" len="med"/>
-                      <a:tailEnd type="none" w="med" len="med"/>
-                    </a:lnR>
-                    <a:lnT w="9525" cap="flat" cmpd="sng" algn="ctr">
-                      <a:solidFill>
-                        <a:srgbClr val="A6A6A6"/>
-                      </a:solidFill>
-                      <a:prstDash val="solid"/>
-                      <a:round/>
-                      <a:headEnd type="none" w="med" len="med"/>
-                      <a:tailEnd type="none" w="med" len="med"/>
-                    </a:lnT>
-                    <a:lnB w="9525" cap="flat" cmpd="sng" algn="ctr">
-                      <a:solidFill>
-                        <a:srgbClr val="A6A6A6"/>
-                      </a:solidFill>
-                      <a:prstDash val="solid"/>
-                      <a:round/>
-                      <a:headEnd type="none" w="med" len="med"/>
-                      <a:tailEnd type="none" w="med" len="med"/>
-                    </a:lnB>
-                    <a:solidFill>
-                      <a:srgbClr val="FFFFFF"/>
-                    </a:solidFill>
-                  </a:tcPr>
-                </a:tc>
-              </a:tr>
             </a:tbl>
           </a:graphicData>
         </a:graphic>
@@ -2749,8 +2312,8 @@
         </p:nvSpPr>
         <p:spPr>
           <a:xfrm>
-            <a:off x="4709160" y="1078992"/>
-            <a:ext cx="4114800" cy="5367528"/>
+            <a:off x="6196432" y="1078992"/>
+            <a:ext cx="5675224" cy="5367528"/>
           </a:xfrm>
           <a:prstGeom prst="rect">
             <a:avLst/>
@@ -2762,7 +2325,7 @@
             <a:solidFill>
               <a:srgbClr val="A6A6A6"/>
             </a:solidFill>
-            <a:prstDash val="dash"/>
+            <a:prstDash val="solid"/>
           </a:ln>
         </p:spPr>
       </p:sp>
@@ -2774,8 +2337,8 @@
         </p:nvSpPr>
         <p:spPr>
           <a:xfrm>
-            <a:off x="4709160" y="1078992"/>
-            <a:ext cx="4114800" cy="5367528"/>
+            <a:off x="6196432" y="3579876"/>
+            <a:ext cx="5675224" cy="365760"/>
           </a:xfrm>
           <a:prstGeom prst="rect">
             <a:avLst/>
@@ -2791,7 +2354,7 @@
               <a:buNone/>
             </a:pPr>
             <a:r>
-              <a:rPr lang="en-US" sz="1100" dirty="0">
+              <a:rPr lang="en-US" sz="1200" dirty="0">
                 <a:solidFill>
                   <a:srgbClr val="9AA0A6"/>
                 </a:solidFill>
@@ -2799,9 +2362,9 @@
                 <a:ea typeface="Malgun Gothic" pitchFamily="34" charset="-122"/>
                 <a:cs typeface="Malgun Gothic" pitchFamily="34" charset="-120"/>
               </a:rPr>
-              <a:t>[ 시스템 아키텍처 다이어그램 ]</a:t>
-            </a:r>
-            <a:endParaRPr lang="en-US" sz="1100" dirty="0"/>
+              <a:t>Overall Architecture</a:t>
+            </a:r>
+            <a:endParaRPr lang="en-US" sz="1200" dirty="0"/>
           </a:p>
         </p:txBody>
       </p:sp>
@@ -2839,7 +2402,7 @@
         <p:spPr>
           <a:xfrm>
             <a:off x="0" y="0"/>
-            <a:ext cx="9144000" cy="914400"/>
+            <a:ext cx="12191695" cy="914400"/>
           </a:xfrm>
           <a:prstGeom prst="rect">
             <a:avLst/>
@@ -2897,7 +2460,7 @@
         </p:nvSpPr>
         <p:spPr>
           <a:xfrm>
-            <a:off x="4160520" y="320040"/>
+            <a:off x="7208215" y="320040"/>
             <a:ext cx="786384" cy="274320"/>
           </a:xfrm>
           <a:prstGeom prst="rect">
@@ -2922,7 +2485,7 @@
         </p:nvSpPr>
         <p:spPr>
           <a:xfrm>
-            <a:off x="4160520" y="320040"/>
+            <a:off x="7208215" y="320040"/>
             <a:ext cx="786384" cy="274320"/>
           </a:xfrm>
           <a:prstGeom prst="rect">
@@ -2961,7 +2524,7 @@
         </p:nvSpPr>
         <p:spPr>
           <a:xfrm>
-            <a:off x="4960620" y="338328"/>
+            <a:off x="8008315" y="338328"/>
             <a:ext cx="155448" cy="237744"/>
           </a:xfrm>
           <a:prstGeom prst="chevron">
@@ -2981,7 +2544,7 @@
         </p:nvSpPr>
         <p:spPr>
           <a:xfrm>
-            <a:off x="5129784" y="320040"/>
+            <a:off x="8177479" y="320040"/>
             <a:ext cx="786384" cy="274320"/>
           </a:xfrm>
           <a:prstGeom prst="rect">
@@ -3006,7 +2569,7 @@
         </p:nvSpPr>
         <p:spPr>
           <a:xfrm>
-            <a:off x="5129784" y="320040"/>
+            <a:off x="8177479" y="320040"/>
             <a:ext cx="786384" cy="274320"/>
           </a:xfrm>
           <a:prstGeom prst="rect">
@@ -3045,7 +2608,7 @@
         </p:nvSpPr>
         <p:spPr>
           <a:xfrm>
-            <a:off x="5929884" y="338328"/>
+            <a:off x="8977579" y="338328"/>
             <a:ext cx="155448" cy="237744"/>
           </a:xfrm>
           <a:prstGeom prst="chevron">
@@ -3065,7 +2628,7 @@
         </p:nvSpPr>
         <p:spPr>
           <a:xfrm>
-            <a:off x="6099048" y="320040"/>
+            <a:off x="9146743" y="320040"/>
             <a:ext cx="786384" cy="274320"/>
           </a:xfrm>
           <a:prstGeom prst="rect">
@@ -3090,7 +2653,7 @@
         </p:nvSpPr>
         <p:spPr>
           <a:xfrm>
-            <a:off x="6099048" y="320040"/>
+            <a:off x="9146743" y="320040"/>
             <a:ext cx="786384" cy="274320"/>
           </a:xfrm>
           <a:prstGeom prst="rect">
@@ -3129,7 +2692,7 @@
         </p:nvSpPr>
         <p:spPr>
           <a:xfrm>
-            <a:off x="6899148" y="338328"/>
+            <a:off x="9946843" y="338328"/>
             <a:ext cx="155448" cy="237744"/>
           </a:xfrm>
           <a:prstGeom prst="chevron">
@@ -3149,7 +2712,7 @@
         </p:nvSpPr>
         <p:spPr>
           <a:xfrm>
-            <a:off x="7068312" y="320040"/>
+            <a:off x="10116007" y="320040"/>
             <a:ext cx="786384" cy="274320"/>
           </a:xfrm>
           <a:prstGeom prst="rect">
@@ -3174,7 +2737,7 @@
         </p:nvSpPr>
         <p:spPr>
           <a:xfrm>
-            <a:off x="7068312" y="320040"/>
+            <a:off x="10116007" y="320040"/>
             <a:ext cx="786384" cy="274320"/>
           </a:xfrm>
           <a:prstGeom prst="rect">
@@ -3213,7 +2776,7 @@
         </p:nvSpPr>
         <p:spPr>
           <a:xfrm>
-            <a:off x="7868412" y="338328"/>
+            <a:off x="10916107" y="338328"/>
             <a:ext cx="155448" cy="237744"/>
           </a:xfrm>
           <a:prstGeom prst="chevron">
@@ -3233,7 +2796,7 @@
         </p:nvSpPr>
         <p:spPr>
           <a:xfrm>
-            <a:off x="8037576" y="320040"/>
+            <a:off x="11085271" y="320040"/>
             <a:ext cx="786384" cy="274320"/>
           </a:xfrm>
           <a:prstGeom prst="rect">
@@ -3258,7 +2821,7 @@
         </p:nvSpPr>
         <p:spPr>
           <a:xfrm>
-            <a:off x="8037576" y="320040"/>
+            <a:off x="11085271" y="320040"/>
             <a:ext cx="786384" cy="274320"/>
           </a:xfrm>
           <a:prstGeom prst="rect">
@@ -3297,7 +2860,7 @@
         </p:nvSpPr>
         <p:spPr>
           <a:xfrm>
-            <a:off x="7680960" y="6492240"/>
+            <a:off x="10728655" y="6492240"/>
             <a:ext cx="1280160" cy="256032"/>
           </a:xfrm>
           <a:prstGeom prst="rect">
@@ -3337,7 +2900,7 @@
         <p:spPr>
           <a:xfrm>
             <a:off x="320040" y="1078992"/>
-            <a:ext cx="2700528" cy="310896"/>
+            <a:ext cx="3716426" cy="310896"/>
           </a:xfrm>
           <a:prstGeom prst="rect">
             <a:avLst/>
@@ -3357,7 +2920,7 @@
         <p:spPr>
           <a:xfrm>
             <a:off x="365760" y="1078992"/>
-            <a:ext cx="2609088" cy="310896"/>
+            <a:ext cx="3624986" cy="310896"/>
           </a:xfrm>
           <a:prstGeom prst="rect">
             <a:avLst/>
@@ -3381,7 +2944,7 @@
                 <a:ea typeface="Malgun Gothic" pitchFamily="34" charset="-122"/>
                 <a:cs typeface="Malgun Gothic" pitchFamily="34" charset="-120"/>
               </a:rPr>
-              <a:t>섹션 헤더 1</a:t>
+              <a:t>배경 헤더 1</a:t>
             </a:r>
             <a:endParaRPr lang="en-US" sz="1300" dirty="0"/>
           </a:p>
@@ -3396,7 +2959,7 @@
         <p:spPr>
           <a:xfrm>
             <a:off x="365760" y="1527048"/>
-            <a:ext cx="2609088" cy="1554480"/>
+            <a:ext cx="3624986" cy="713232"/>
           </a:xfrm>
           <a:prstGeom prst="rect">
             <a:avLst/>
@@ -3424,10 +2987,57 @@
                 <a:ea typeface="Malgun Gothic" pitchFamily="34" charset="-122"/>
                 <a:cs typeface="Malgun Gothic" pitchFamily="34" charset="-120"/>
               </a:rPr>
-              <a:t>핵심 메시지 문장을 여기에 작성</a:t>
+              <a:t>첫 번째 핵심 메시지</a:t>
             </a:r>
             <a:endParaRPr lang="en-US" sz="1100" dirty="0"/>
           </a:p>
+        </p:txBody>
+      </p:sp>
+      <p:sp>
+        <p:nvSpPr>
+          <p:cNvPr id="22" name="Shape 20"/>
+          <p:cNvSpPr/>
+          <p:nvPr/>
+        </p:nvSpPr>
+        <p:spPr>
+          <a:xfrm>
+            <a:off x="320040" y="2286000"/>
+            <a:ext cx="3716426" cy="1618488"/>
+          </a:xfrm>
+          <a:prstGeom prst="rect">
+            <a:avLst/>
+          </a:prstGeom>
+          <a:solidFill>
+            <a:srgbClr val="F5F6F8"/>
+          </a:solidFill>
+          <a:ln w="12700">
+            <a:solidFill>
+              <a:srgbClr val="A6A6A6"/>
+            </a:solidFill>
+            <a:prstDash val="solid"/>
+          </a:ln>
+        </p:spPr>
+      </p:sp>
+      <p:sp>
+        <p:nvSpPr>
+          <p:cNvPr id="23" name="Text 21"/>
+          <p:cNvSpPr/>
+          <p:nvPr/>
+        </p:nvSpPr>
+        <p:spPr>
+          <a:xfrm>
+            <a:off x="365760" y="4069080"/>
+            <a:ext cx="3624986" cy="713232"/>
+          </a:xfrm>
+          <a:prstGeom prst="rect">
+            <a:avLst/>
+          </a:prstGeom>
+          <a:noFill/>
+          <a:ln/>
+        </p:spPr>
+        <p:txBody>
+          <a:bodyPr wrap="square" lIns="0" tIns="0" rIns="0" bIns="0" rtlCol="0" anchor="t"/>
+          <a:lstStyle/>
           <a:p>
             <a:pPr algn="l" marL="177800" indent="-177800">
               <a:spcAft>
@@ -3453,14 +3063,14 @@
       </p:sp>
       <p:sp>
         <p:nvSpPr>
-          <p:cNvPr id="22" name="Shape 20"/>
-          <p:cNvSpPr/>
-          <p:nvPr/>
-        </p:nvSpPr>
-        <p:spPr>
-          <a:xfrm>
-            <a:off x="320040" y="3172968"/>
-            <a:ext cx="2700528" cy="2606040"/>
+          <p:cNvPr id="24" name="Shape 22"/>
+          <p:cNvSpPr/>
+          <p:nvPr/>
+        </p:nvSpPr>
+        <p:spPr>
+          <a:xfrm>
+            <a:off x="320040" y="4828032"/>
+            <a:ext cx="3716426" cy="1618488"/>
           </a:xfrm>
           <a:prstGeom prst="rect">
             <a:avLst/>
@@ -3472,59 +3082,20 @@
             <a:solidFill>
               <a:srgbClr val="A6A6A6"/>
             </a:solidFill>
-            <a:prstDash val="dash"/>
+            <a:prstDash val="solid"/>
           </a:ln>
         </p:spPr>
       </p:sp>
       <p:sp>
         <p:nvSpPr>
-          <p:cNvPr id="23" name="Text 21"/>
-          <p:cNvSpPr/>
-          <p:nvPr/>
-        </p:nvSpPr>
-        <p:spPr>
-          <a:xfrm>
-            <a:off x="320040" y="3172968"/>
-            <a:ext cx="2700528" cy="2606040"/>
-          </a:xfrm>
-          <a:prstGeom prst="rect">
-            <a:avLst/>
-          </a:prstGeom>
-          <a:noFill/>
-          <a:ln/>
-        </p:spPr>
-        <p:txBody>
-          <a:bodyPr wrap="square" rtlCol="0" anchor="ctr"/>
-          <a:lstStyle/>
-          <a:p>
-            <a:pPr algn="ctr" indent="0" marL="0">
-              <a:buNone/>
-            </a:pPr>
-            <a:r>
-              <a:rPr lang="en-US" sz="1100" dirty="0">
-                <a:solidFill>
-                  <a:srgbClr val="9AA0A6"/>
-                </a:solidFill>
-                <a:latin typeface="Malgun Gothic" pitchFamily="34" charset="0"/>
-                <a:ea typeface="Malgun Gothic" pitchFamily="34" charset="-122"/>
-                <a:cs typeface="Malgun Gothic" pitchFamily="34" charset="-120"/>
-              </a:rPr>
-              <a:t>[ 그림 / 차트 ]</a:t>
-            </a:r>
-            <a:endParaRPr lang="en-US" sz="1100" dirty="0"/>
-          </a:p>
-        </p:txBody>
-      </p:sp>
-      <p:sp>
-        <p:nvSpPr>
-          <p:cNvPr id="24" name="Shape 22"/>
-          <p:cNvSpPr/>
-          <p:nvPr/>
-        </p:nvSpPr>
-        <p:spPr>
-          <a:xfrm>
-            <a:off x="3221736" y="1078992"/>
-            <a:ext cx="2700528" cy="310896"/>
+          <p:cNvPr id="25" name="Shape 23"/>
+          <p:cNvSpPr/>
+          <p:nvPr/>
+        </p:nvSpPr>
+        <p:spPr>
+          <a:xfrm>
+            <a:off x="4237634" y="1078992"/>
+            <a:ext cx="3716426" cy="310896"/>
           </a:xfrm>
           <a:prstGeom prst="rect">
             <a:avLst/>
@@ -3537,14 +3108,14 @@
       </p:sp>
       <p:sp>
         <p:nvSpPr>
-          <p:cNvPr id="25" name="Text 23"/>
-          <p:cNvSpPr/>
-          <p:nvPr/>
-        </p:nvSpPr>
-        <p:spPr>
-          <a:xfrm>
-            <a:off x="3267456" y="1078992"/>
-            <a:ext cx="2609088" cy="310896"/>
+          <p:cNvPr id="26" name="Text 24"/>
+          <p:cNvSpPr/>
+          <p:nvPr/>
+        </p:nvSpPr>
+        <p:spPr>
+          <a:xfrm>
+            <a:off x="4283354" y="1078992"/>
+            <a:ext cx="3624986" cy="310896"/>
           </a:xfrm>
           <a:prstGeom prst="rect">
             <a:avLst/>
@@ -3568,7 +3139,7 @@
                 <a:ea typeface="Malgun Gothic" pitchFamily="34" charset="-122"/>
                 <a:cs typeface="Malgun Gothic" pitchFamily="34" charset="-120"/>
               </a:rPr>
-              <a:t>섹션 헤더 2</a:t>
+              <a:t>배경 헤더 2</a:t>
             </a:r>
             <a:endParaRPr lang="en-US" sz="1300" dirty="0"/>
           </a:p>
@@ -3576,14 +3147,14 @@
       </p:sp>
       <p:sp>
         <p:nvSpPr>
-          <p:cNvPr id="26" name="Text 24"/>
-          <p:cNvSpPr/>
-          <p:nvPr/>
-        </p:nvSpPr>
-        <p:spPr>
-          <a:xfrm>
-            <a:off x="3267456" y="1527048"/>
-            <a:ext cx="2609088" cy="1554480"/>
+          <p:cNvPr id="27" name="Text 25"/>
+          <p:cNvSpPr/>
+          <p:nvPr/>
+        </p:nvSpPr>
+        <p:spPr>
+          <a:xfrm>
+            <a:off x="4283354" y="1527048"/>
+            <a:ext cx="3624986" cy="713232"/>
           </a:xfrm>
           <a:prstGeom prst="rect">
             <a:avLst/>
@@ -3611,10 +3182,57 @@
                 <a:ea typeface="Malgun Gothic" pitchFamily="34" charset="-122"/>
                 <a:cs typeface="Malgun Gothic" pitchFamily="34" charset="-120"/>
               </a:rPr>
-              <a:t>핵심 메시지 문장을 여기에 작성</a:t>
+              <a:t>첫 번째 핵심 메시지</a:t>
             </a:r>
             <a:endParaRPr lang="en-US" sz="1100" dirty="0"/>
           </a:p>
+        </p:txBody>
+      </p:sp>
+      <p:sp>
+        <p:nvSpPr>
+          <p:cNvPr id="28" name="Shape 26"/>
+          <p:cNvSpPr/>
+          <p:nvPr/>
+        </p:nvSpPr>
+        <p:spPr>
+          <a:xfrm>
+            <a:off x="4237634" y="2286000"/>
+            <a:ext cx="3716426" cy="1618488"/>
+          </a:xfrm>
+          <a:prstGeom prst="rect">
+            <a:avLst/>
+          </a:prstGeom>
+          <a:solidFill>
+            <a:srgbClr val="F5F6F8"/>
+          </a:solidFill>
+          <a:ln w="12700">
+            <a:solidFill>
+              <a:srgbClr val="A6A6A6"/>
+            </a:solidFill>
+            <a:prstDash val="solid"/>
+          </a:ln>
+        </p:spPr>
+      </p:sp>
+      <p:sp>
+        <p:nvSpPr>
+          <p:cNvPr id="29" name="Text 27"/>
+          <p:cNvSpPr/>
+          <p:nvPr/>
+        </p:nvSpPr>
+        <p:spPr>
+          <a:xfrm>
+            <a:off x="4283354" y="4069080"/>
+            <a:ext cx="3624986" cy="713232"/>
+          </a:xfrm>
+          <a:prstGeom prst="rect">
+            <a:avLst/>
+          </a:prstGeom>
+          <a:noFill/>
+          <a:ln/>
+        </p:spPr>
+        <p:txBody>
+          <a:bodyPr wrap="square" lIns="0" tIns="0" rIns="0" bIns="0" rtlCol="0" anchor="t"/>
+          <a:lstStyle/>
           <a:p>
             <a:pPr algn="l" marL="177800" indent="-177800">
               <a:spcAft>
@@ -3640,14 +3258,14 @@
       </p:sp>
       <p:sp>
         <p:nvSpPr>
-          <p:cNvPr id="27" name="Shape 25"/>
-          <p:cNvSpPr/>
-          <p:nvPr/>
-        </p:nvSpPr>
-        <p:spPr>
-          <a:xfrm>
-            <a:off x="3221736" y="3172968"/>
-            <a:ext cx="2700528" cy="2606040"/>
+          <p:cNvPr id="30" name="Shape 28"/>
+          <p:cNvSpPr/>
+          <p:nvPr/>
+        </p:nvSpPr>
+        <p:spPr>
+          <a:xfrm>
+            <a:off x="4237634" y="4828032"/>
+            <a:ext cx="3716426" cy="1618488"/>
           </a:xfrm>
           <a:prstGeom prst="rect">
             <a:avLst/>
@@ -3659,59 +3277,20 @@
             <a:solidFill>
               <a:srgbClr val="A6A6A6"/>
             </a:solidFill>
-            <a:prstDash val="dash"/>
+            <a:prstDash val="solid"/>
           </a:ln>
         </p:spPr>
       </p:sp>
       <p:sp>
         <p:nvSpPr>
-          <p:cNvPr id="28" name="Text 26"/>
-          <p:cNvSpPr/>
-          <p:nvPr/>
-        </p:nvSpPr>
-        <p:spPr>
-          <a:xfrm>
-            <a:off x="3221736" y="3172968"/>
-            <a:ext cx="2700528" cy="2606040"/>
-          </a:xfrm>
-          <a:prstGeom prst="rect">
-            <a:avLst/>
-          </a:prstGeom>
-          <a:noFill/>
-          <a:ln/>
-        </p:spPr>
-        <p:txBody>
-          <a:bodyPr wrap="square" rtlCol="0" anchor="ctr"/>
-          <a:lstStyle/>
-          <a:p>
-            <a:pPr algn="ctr" indent="0" marL="0">
-              <a:buNone/>
-            </a:pPr>
-            <a:r>
-              <a:rPr lang="en-US" sz="1100" dirty="0">
-                <a:solidFill>
-                  <a:srgbClr val="9AA0A6"/>
-                </a:solidFill>
-                <a:latin typeface="Malgun Gothic" pitchFamily="34" charset="0"/>
-                <a:ea typeface="Malgun Gothic" pitchFamily="34" charset="-122"/>
-                <a:cs typeface="Malgun Gothic" pitchFamily="34" charset="-120"/>
-              </a:rPr>
-              <a:t>[ 그림 / 차트 ]</a:t>
-            </a:r>
-            <a:endParaRPr lang="en-US" sz="1100" dirty="0"/>
-          </a:p>
-        </p:txBody>
-      </p:sp>
-      <p:sp>
-        <p:nvSpPr>
-          <p:cNvPr id="29" name="Shape 27"/>
-          <p:cNvSpPr/>
-          <p:nvPr/>
-        </p:nvSpPr>
-        <p:spPr>
-          <a:xfrm>
-            <a:off x="6123432" y="1078992"/>
-            <a:ext cx="2700528" cy="310896"/>
+          <p:cNvPr id="31" name="Shape 29"/>
+          <p:cNvSpPr/>
+          <p:nvPr/>
+        </p:nvSpPr>
+        <p:spPr>
+          <a:xfrm>
+            <a:off x="8155229" y="1078992"/>
+            <a:ext cx="3716426" cy="310896"/>
           </a:xfrm>
           <a:prstGeom prst="rect">
             <a:avLst/>
@@ -3724,14 +3303,14 @@
       </p:sp>
       <p:sp>
         <p:nvSpPr>
-          <p:cNvPr id="30" name="Text 28"/>
-          <p:cNvSpPr/>
-          <p:nvPr/>
-        </p:nvSpPr>
-        <p:spPr>
-          <a:xfrm>
-            <a:off x="6169152" y="1078992"/>
-            <a:ext cx="2609088" cy="310896"/>
+          <p:cNvPr id="32" name="Text 30"/>
+          <p:cNvSpPr/>
+          <p:nvPr/>
+        </p:nvSpPr>
+        <p:spPr>
+          <a:xfrm>
+            <a:off x="8200949" y="1078992"/>
+            <a:ext cx="3624986" cy="310896"/>
           </a:xfrm>
           <a:prstGeom prst="rect">
             <a:avLst/>
@@ -3755,7 +3334,7 @@
                 <a:ea typeface="Malgun Gothic" pitchFamily="34" charset="-122"/>
                 <a:cs typeface="Malgun Gothic" pitchFamily="34" charset="-120"/>
               </a:rPr>
-              <a:t>섹션 헤더 3</a:t>
+              <a:t>배경 헤더 3</a:t>
             </a:r>
             <a:endParaRPr lang="en-US" sz="1300" dirty="0"/>
           </a:p>
@@ -3763,14 +3342,14 @@
       </p:sp>
       <p:sp>
         <p:nvSpPr>
-          <p:cNvPr id="31" name="Text 29"/>
-          <p:cNvSpPr/>
-          <p:nvPr/>
-        </p:nvSpPr>
-        <p:spPr>
-          <a:xfrm>
-            <a:off x="6169152" y="1527048"/>
-            <a:ext cx="2609088" cy="1554480"/>
+          <p:cNvPr id="33" name="Text 31"/>
+          <p:cNvSpPr/>
+          <p:nvPr/>
+        </p:nvSpPr>
+        <p:spPr>
+          <a:xfrm>
+            <a:off x="8200949" y="1527048"/>
+            <a:ext cx="3624986" cy="713232"/>
           </a:xfrm>
           <a:prstGeom prst="rect">
             <a:avLst/>
@@ -3798,10 +3377,57 @@
                 <a:ea typeface="Malgun Gothic" pitchFamily="34" charset="-122"/>
                 <a:cs typeface="Malgun Gothic" pitchFamily="34" charset="-120"/>
               </a:rPr>
-              <a:t>핵심 메시지 문장을 여기에 작성</a:t>
+              <a:t>첫 번째 핵심 메시지</a:t>
             </a:r>
             <a:endParaRPr lang="en-US" sz="1100" dirty="0"/>
           </a:p>
+        </p:txBody>
+      </p:sp>
+      <p:sp>
+        <p:nvSpPr>
+          <p:cNvPr id="34" name="Shape 32"/>
+          <p:cNvSpPr/>
+          <p:nvPr/>
+        </p:nvSpPr>
+        <p:spPr>
+          <a:xfrm>
+            <a:off x="8155229" y="2286000"/>
+            <a:ext cx="3716426" cy="1618488"/>
+          </a:xfrm>
+          <a:prstGeom prst="rect">
+            <a:avLst/>
+          </a:prstGeom>
+          <a:solidFill>
+            <a:srgbClr val="F5F6F8"/>
+          </a:solidFill>
+          <a:ln w="12700">
+            <a:solidFill>
+              <a:srgbClr val="A6A6A6"/>
+            </a:solidFill>
+            <a:prstDash val="solid"/>
+          </a:ln>
+        </p:spPr>
+      </p:sp>
+      <p:sp>
+        <p:nvSpPr>
+          <p:cNvPr id="35" name="Text 33"/>
+          <p:cNvSpPr/>
+          <p:nvPr/>
+        </p:nvSpPr>
+        <p:spPr>
+          <a:xfrm>
+            <a:off x="8200949" y="4069080"/>
+            <a:ext cx="3624986" cy="713232"/>
+          </a:xfrm>
+          <a:prstGeom prst="rect">
+            <a:avLst/>
+          </a:prstGeom>
+          <a:noFill/>
+          <a:ln/>
+        </p:spPr>
+        <p:txBody>
+          <a:bodyPr wrap="square" lIns="0" tIns="0" rIns="0" bIns="0" rtlCol="0" anchor="t"/>
+          <a:lstStyle/>
           <a:p>
             <a:pPr algn="l" marL="177800" indent="-177800">
               <a:spcAft>
@@ -3827,14 +3453,14 @@
       </p:sp>
       <p:sp>
         <p:nvSpPr>
-          <p:cNvPr id="32" name="Shape 30"/>
-          <p:cNvSpPr/>
-          <p:nvPr/>
-        </p:nvSpPr>
-        <p:spPr>
-          <a:xfrm>
-            <a:off x="6123432" y="3172968"/>
-            <a:ext cx="2700528" cy="2606040"/>
+          <p:cNvPr id="36" name="Shape 34"/>
+          <p:cNvSpPr/>
+          <p:nvPr/>
+        </p:nvSpPr>
+        <p:spPr>
+          <a:xfrm>
+            <a:off x="8155229" y="4828032"/>
+            <a:ext cx="3716426" cy="1618488"/>
           </a:xfrm>
           <a:prstGeom prst="rect">
             <a:avLst/>
@@ -3846,48 +3472,9 @@
             <a:solidFill>
               <a:srgbClr val="A6A6A6"/>
             </a:solidFill>
-            <a:prstDash val="dash"/>
+            <a:prstDash val="solid"/>
           </a:ln>
         </p:spPr>
-      </p:sp>
-      <p:sp>
-        <p:nvSpPr>
-          <p:cNvPr id="33" name="Text 31"/>
-          <p:cNvSpPr/>
-          <p:nvPr/>
-        </p:nvSpPr>
-        <p:spPr>
-          <a:xfrm>
-            <a:off x="6123432" y="3172968"/>
-            <a:ext cx="2700528" cy="2606040"/>
-          </a:xfrm>
-          <a:prstGeom prst="rect">
-            <a:avLst/>
-          </a:prstGeom>
-          <a:noFill/>
-          <a:ln/>
-        </p:spPr>
-        <p:txBody>
-          <a:bodyPr wrap="square" rtlCol="0" anchor="ctr"/>
-          <a:lstStyle/>
-          <a:p>
-            <a:pPr algn="ctr" indent="0" marL="0">
-              <a:buNone/>
-            </a:pPr>
-            <a:r>
-              <a:rPr lang="en-US" sz="1100" dirty="0">
-                <a:solidFill>
-                  <a:srgbClr val="9AA0A6"/>
-                </a:solidFill>
-                <a:latin typeface="Malgun Gothic" pitchFamily="34" charset="0"/>
-                <a:ea typeface="Malgun Gothic" pitchFamily="34" charset="-122"/>
-                <a:cs typeface="Malgun Gothic" pitchFamily="34" charset="-120"/>
-              </a:rPr>
-              <a:t>[ 그림 / 차트 ]</a:t>
-            </a:r>
-            <a:endParaRPr lang="en-US" sz="1100" dirty="0"/>
-          </a:p>
-        </p:txBody>
       </p:sp>
     </p:spTree>
   </p:cSld>
@@ -3923,7 +3510,920 @@
         <p:spPr>
           <a:xfrm>
             <a:off x="0" y="0"/>
-            <a:ext cx="9144000" cy="914400"/>
+            <a:ext cx="12191695" cy="914400"/>
+          </a:xfrm>
+          <a:prstGeom prst="rect">
+            <a:avLst/>
+          </a:prstGeom>
+          <a:solidFill>
+            <a:srgbClr val="1F3864"/>
+          </a:solidFill>
+          <a:ln/>
+        </p:spPr>
+      </p:sp>
+      <p:sp>
+        <p:nvSpPr>
+          <p:cNvPr id="3" name="Text 1"/>
+          <p:cNvSpPr/>
+          <p:nvPr/>
+        </p:nvSpPr>
+        <p:spPr>
+          <a:xfrm>
+            <a:off x="320040" y="109728"/>
+            <a:ext cx="4572000" cy="694944"/>
+          </a:xfrm>
+          <a:prstGeom prst="rect">
+            <a:avLst/>
+          </a:prstGeom>
+          <a:noFill/>
+          <a:ln/>
+        </p:spPr>
+        <p:txBody>
+          <a:bodyPr wrap="square" lIns="0" tIns="0" rIns="0" bIns="0" rtlCol="0" anchor="ctr"/>
+          <a:lstStyle/>
+          <a:p>
+            <a:pPr algn="l" indent="0" marL="0">
+              <a:buNone/>
+            </a:pPr>
+            <a:r>
+              <a:rPr lang="en-US" sz="3000" b="1" dirty="0">
+                <a:solidFill>
+                  <a:srgbClr val="FFFFFF"/>
+                </a:solidFill>
+                <a:latin typeface="Malgun Gothic" pitchFamily="34" charset="0"/>
+                <a:ea typeface="Malgun Gothic" pitchFamily="34" charset="-122"/>
+                <a:cs typeface="Malgun Gothic" pitchFamily="34" charset="-120"/>
+              </a:rPr>
+              <a:t>과제 필요성</a:t>
+            </a:r>
+            <a:endParaRPr lang="en-US" sz="3000" dirty="0"/>
+          </a:p>
+        </p:txBody>
+      </p:sp>
+      <p:sp>
+        <p:nvSpPr>
+          <p:cNvPr id="4" name="Shape 2"/>
+          <p:cNvSpPr/>
+          <p:nvPr/>
+        </p:nvSpPr>
+        <p:spPr>
+          <a:xfrm>
+            <a:off x="7208215" y="320040"/>
+            <a:ext cx="786384" cy="274320"/>
+          </a:xfrm>
+          <a:prstGeom prst="rect">
+            <a:avLst/>
+          </a:prstGeom>
+          <a:solidFill>
+            <a:srgbClr val="FFC000"/>
+          </a:solidFill>
+          <a:ln w="9525">
+            <a:solidFill>
+              <a:srgbClr val="FFC000"/>
+            </a:solidFill>
+            <a:prstDash val="solid"/>
+          </a:ln>
+        </p:spPr>
+      </p:sp>
+      <p:sp>
+        <p:nvSpPr>
+          <p:cNvPr id="5" name="Text 3"/>
+          <p:cNvSpPr/>
+          <p:nvPr/>
+        </p:nvSpPr>
+        <p:spPr>
+          <a:xfrm>
+            <a:off x="7208215" y="320040"/>
+            <a:ext cx="786384" cy="274320"/>
+          </a:xfrm>
+          <a:prstGeom prst="rect">
+            <a:avLst/>
+          </a:prstGeom>
+          <a:noFill/>
+          <a:ln/>
+        </p:spPr>
+        <p:txBody>
+          <a:bodyPr wrap="square" lIns="0" tIns="0" rIns="0" bIns="0" rtlCol="0" anchor="ctr"/>
+          <a:lstStyle/>
+          <a:p>
+            <a:pPr algn="ctr" indent="0" marL="0">
+              <a:buNone/>
+            </a:pPr>
+            <a:r>
+              <a:rPr lang="en-US" sz="900" b="1" dirty="0">
+                <a:solidFill>
+                  <a:srgbClr val="1F3864"/>
+                </a:solidFill>
+                <a:latin typeface="Malgun Gothic" pitchFamily="34" charset="0"/>
+                <a:ea typeface="Malgun Gothic" pitchFamily="34" charset="-122"/>
+                <a:cs typeface="Malgun Gothic" pitchFamily="34" charset="-120"/>
+              </a:rPr>
+              <a:t>과제 개요</a:t>
+            </a:r>
+            <a:endParaRPr lang="en-US" sz="900" dirty="0"/>
+          </a:p>
+        </p:txBody>
+      </p:sp>
+      <p:sp>
+        <p:nvSpPr>
+          <p:cNvPr id="6" name="Shape 4"/>
+          <p:cNvSpPr/>
+          <p:nvPr/>
+        </p:nvSpPr>
+        <p:spPr>
+          <a:xfrm>
+            <a:off x="8008315" y="338328"/>
+            <a:ext cx="155448" cy="237744"/>
+          </a:xfrm>
+          <a:prstGeom prst="chevron">
+            <a:avLst/>
+          </a:prstGeom>
+          <a:solidFill>
+            <a:srgbClr val="9AA0A6"/>
+          </a:solidFill>
+          <a:ln/>
+        </p:spPr>
+      </p:sp>
+      <p:sp>
+        <p:nvSpPr>
+          <p:cNvPr id="7" name="Shape 5"/>
+          <p:cNvSpPr/>
+          <p:nvPr/>
+        </p:nvSpPr>
+        <p:spPr>
+          <a:xfrm>
+            <a:off x="8177479" y="320040"/>
+            <a:ext cx="786384" cy="274320"/>
+          </a:xfrm>
+          <a:prstGeom prst="rect">
+            <a:avLst/>
+          </a:prstGeom>
+          <a:solidFill>
+            <a:srgbClr val="E9E9E9"/>
+          </a:solidFill>
+          <a:ln w="9525">
+            <a:solidFill>
+              <a:srgbClr val="A6A6A6"/>
+            </a:solidFill>
+            <a:prstDash val="solid"/>
+          </a:ln>
+        </p:spPr>
+      </p:sp>
+      <p:sp>
+        <p:nvSpPr>
+          <p:cNvPr id="8" name="Text 6"/>
+          <p:cNvSpPr/>
+          <p:nvPr/>
+        </p:nvSpPr>
+        <p:spPr>
+          <a:xfrm>
+            <a:off x="8177479" y="320040"/>
+            <a:ext cx="786384" cy="274320"/>
+          </a:xfrm>
+          <a:prstGeom prst="rect">
+            <a:avLst/>
+          </a:prstGeom>
+          <a:noFill/>
+          <a:ln/>
+        </p:spPr>
+        <p:txBody>
+          <a:bodyPr wrap="square" lIns="0" tIns="0" rIns="0" bIns="0" rtlCol="0" anchor="ctr"/>
+          <a:lstStyle/>
+          <a:p>
+            <a:pPr algn="ctr" indent="0" marL="0">
+              <a:buNone/>
+            </a:pPr>
+            <a:r>
+              <a:rPr lang="en-US" sz="900" dirty="0">
+                <a:solidFill>
+                  <a:srgbClr val="595959"/>
+                </a:solidFill>
+                <a:latin typeface="Malgun Gothic" pitchFamily="34" charset="0"/>
+                <a:ea typeface="Malgun Gothic" pitchFamily="34" charset="-122"/>
+                <a:cs typeface="Malgun Gothic" pitchFamily="34" charset="-120"/>
+              </a:rPr>
+              <a:t>요구사항</a:t>
+            </a:r>
+            <a:endParaRPr lang="en-US" sz="900" dirty="0"/>
+          </a:p>
+        </p:txBody>
+      </p:sp>
+      <p:sp>
+        <p:nvSpPr>
+          <p:cNvPr id="9" name="Shape 7"/>
+          <p:cNvSpPr/>
+          <p:nvPr/>
+        </p:nvSpPr>
+        <p:spPr>
+          <a:xfrm>
+            <a:off x="8977579" y="338328"/>
+            <a:ext cx="155448" cy="237744"/>
+          </a:xfrm>
+          <a:prstGeom prst="chevron">
+            <a:avLst/>
+          </a:prstGeom>
+          <a:solidFill>
+            <a:srgbClr val="9AA0A6"/>
+          </a:solidFill>
+          <a:ln/>
+        </p:spPr>
+      </p:sp>
+      <p:sp>
+        <p:nvSpPr>
+          <p:cNvPr id="10" name="Shape 8"/>
+          <p:cNvSpPr/>
+          <p:nvPr/>
+        </p:nvSpPr>
+        <p:spPr>
+          <a:xfrm>
+            <a:off x="9146743" y="320040"/>
+            <a:ext cx="786384" cy="274320"/>
+          </a:xfrm>
+          <a:prstGeom prst="rect">
+            <a:avLst/>
+          </a:prstGeom>
+          <a:solidFill>
+            <a:srgbClr val="E9E9E9"/>
+          </a:solidFill>
+          <a:ln w="9525">
+            <a:solidFill>
+              <a:srgbClr val="A6A6A6"/>
+            </a:solidFill>
+            <a:prstDash val="solid"/>
+          </a:ln>
+        </p:spPr>
+      </p:sp>
+      <p:sp>
+        <p:nvSpPr>
+          <p:cNvPr id="11" name="Text 9"/>
+          <p:cNvSpPr/>
+          <p:nvPr/>
+        </p:nvSpPr>
+        <p:spPr>
+          <a:xfrm>
+            <a:off x="9146743" y="320040"/>
+            <a:ext cx="786384" cy="274320"/>
+          </a:xfrm>
+          <a:prstGeom prst="rect">
+            <a:avLst/>
+          </a:prstGeom>
+          <a:noFill/>
+          <a:ln/>
+        </p:spPr>
+        <p:txBody>
+          <a:bodyPr wrap="square" lIns="0" tIns="0" rIns="0" bIns="0" rtlCol="0" anchor="ctr"/>
+          <a:lstStyle/>
+          <a:p>
+            <a:pPr algn="ctr" indent="0" marL="0">
+              <a:buNone/>
+            </a:pPr>
+            <a:r>
+              <a:rPr lang="en-US" sz="900" dirty="0">
+                <a:solidFill>
+                  <a:srgbClr val="595959"/>
+                </a:solidFill>
+                <a:latin typeface="Malgun Gothic" pitchFamily="34" charset="0"/>
+                <a:ea typeface="Malgun Gothic" pitchFamily="34" charset="-122"/>
+                <a:cs typeface="Malgun Gothic" pitchFamily="34" charset="-120"/>
+              </a:rPr>
+              <a:t>설계</a:t>
+            </a:r>
+            <a:endParaRPr lang="en-US" sz="900" dirty="0"/>
+          </a:p>
+        </p:txBody>
+      </p:sp>
+      <p:sp>
+        <p:nvSpPr>
+          <p:cNvPr id="12" name="Shape 10"/>
+          <p:cNvSpPr/>
+          <p:nvPr/>
+        </p:nvSpPr>
+        <p:spPr>
+          <a:xfrm>
+            <a:off x="9946843" y="338328"/>
+            <a:ext cx="155448" cy="237744"/>
+          </a:xfrm>
+          <a:prstGeom prst="chevron">
+            <a:avLst/>
+          </a:prstGeom>
+          <a:solidFill>
+            <a:srgbClr val="9AA0A6"/>
+          </a:solidFill>
+          <a:ln/>
+        </p:spPr>
+      </p:sp>
+      <p:sp>
+        <p:nvSpPr>
+          <p:cNvPr id="13" name="Shape 11"/>
+          <p:cNvSpPr/>
+          <p:nvPr/>
+        </p:nvSpPr>
+        <p:spPr>
+          <a:xfrm>
+            <a:off x="10116007" y="320040"/>
+            <a:ext cx="786384" cy="274320"/>
+          </a:xfrm>
+          <a:prstGeom prst="rect">
+            <a:avLst/>
+          </a:prstGeom>
+          <a:solidFill>
+            <a:srgbClr val="E9E9E9"/>
+          </a:solidFill>
+          <a:ln w="9525">
+            <a:solidFill>
+              <a:srgbClr val="A6A6A6"/>
+            </a:solidFill>
+            <a:prstDash val="solid"/>
+          </a:ln>
+        </p:spPr>
+      </p:sp>
+      <p:sp>
+        <p:nvSpPr>
+          <p:cNvPr id="14" name="Text 12"/>
+          <p:cNvSpPr/>
+          <p:nvPr/>
+        </p:nvSpPr>
+        <p:spPr>
+          <a:xfrm>
+            <a:off x="10116007" y="320040"/>
+            <a:ext cx="786384" cy="274320"/>
+          </a:xfrm>
+          <a:prstGeom prst="rect">
+            <a:avLst/>
+          </a:prstGeom>
+          <a:noFill/>
+          <a:ln/>
+        </p:spPr>
+        <p:txBody>
+          <a:bodyPr wrap="square" lIns="0" tIns="0" rIns="0" bIns="0" rtlCol="0" anchor="ctr"/>
+          <a:lstStyle/>
+          <a:p>
+            <a:pPr algn="ctr" indent="0" marL="0">
+              <a:buNone/>
+            </a:pPr>
+            <a:r>
+              <a:rPr lang="en-US" sz="900" dirty="0">
+                <a:solidFill>
+                  <a:srgbClr val="595959"/>
+                </a:solidFill>
+                <a:latin typeface="Malgun Gothic" pitchFamily="34" charset="0"/>
+                <a:ea typeface="Malgun Gothic" pitchFamily="34" charset="-122"/>
+                <a:cs typeface="Malgun Gothic" pitchFamily="34" charset="-120"/>
+              </a:rPr>
+              <a:t>검증</a:t>
+            </a:r>
+            <a:endParaRPr lang="en-US" sz="900" dirty="0"/>
+          </a:p>
+        </p:txBody>
+      </p:sp>
+      <p:sp>
+        <p:nvSpPr>
+          <p:cNvPr id="15" name="Shape 13"/>
+          <p:cNvSpPr/>
+          <p:nvPr/>
+        </p:nvSpPr>
+        <p:spPr>
+          <a:xfrm>
+            <a:off x="10916107" y="338328"/>
+            <a:ext cx="155448" cy="237744"/>
+          </a:xfrm>
+          <a:prstGeom prst="chevron">
+            <a:avLst/>
+          </a:prstGeom>
+          <a:solidFill>
+            <a:srgbClr val="9AA0A6"/>
+          </a:solidFill>
+          <a:ln/>
+        </p:spPr>
+      </p:sp>
+      <p:sp>
+        <p:nvSpPr>
+          <p:cNvPr id="16" name="Shape 14"/>
+          <p:cNvSpPr/>
+          <p:nvPr/>
+        </p:nvSpPr>
+        <p:spPr>
+          <a:xfrm>
+            <a:off x="11085271" y="320040"/>
+            <a:ext cx="786384" cy="274320"/>
+          </a:xfrm>
+          <a:prstGeom prst="rect">
+            <a:avLst/>
+          </a:prstGeom>
+          <a:solidFill>
+            <a:srgbClr val="E9E9E9"/>
+          </a:solidFill>
+          <a:ln w="9525">
+            <a:solidFill>
+              <a:srgbClr val="A6A6A6"/>
+            </a:solidFill>
+            <a:prstDash val="solid"/>
+          </a:ln>
+        </p:spPr>
+      </p:sp>
+      <p:sp>
+        <p:nvSpPr>
+          <p:cNvPr id="17" name="Text 15"/>
+          <p:cNvSpPr/>
+          <p:nvPr/>
+        </p:nvSpPr>
+        <p:spPr>
+          <a:xfrm>
+            <a:off x="11085271" y="320040"/>
+            <a:ext cx="786384" cy="274320"/>
+          </a:xfrm>
+          <a:prstGeom prst="rect">
+            <a:avLst/>
+          </a:prstGeom>
+          <a:noFill/>
+          <a:ln/>
+        </p:spPr>
+        <p:txBody>
+          <a:bodyPr wrap="square" lIns="0" tIns="0" rIns="0" bIns="0" rtlCol="0" anchor="ctr"/>
+          <a:lstStyle/>
+          <a:p>
+            <a:pPr algn="ctr" indent="0" marL="0">
+              <a:buNone/>
+            </a:pPr>
+            <a:r>
+              <a:rPr lang="en-US" sz="900" dirty="0">
+                <a:solidFill>
+                  <a:srgbClr val="595959"/>
+                </a:solidFill>
+                <a:latin typeface="Malgun Gothic" pitchFamily="34" charset="0"/>
+                <a:ea typeface="Malgun Gothic" pitchFamily="34" charset="-122"/>
+                <a:cs typeface="Malgun Gothic" pitchFamily="34" charset="-120"/>
+              </a:rPr>
+              <a:t>결론</a:t>
+            </a:r>
+            <a:endParaRPr lang="en-US" sz="900" dirty="0"/>
+          </a:p>
+        </p:txBody>
+      </p:sp>
+      <p:sp>
+        <p:nvSpPr>
+          <p:cNvPr id="18" name="Text 16"/>
+          <p:cNvSpPr/>
+          <p:nvPr/>
+        </p:nvSpPr>
+        <p:spPr>
+          <a:xfrm>
+            <a:off x="10728655" y="6492240"/>
+            <a:ext cx="1280160" cy="256032"/>
+          </a:xfrm>
+          <a:prstGeom prst="rect">
+            <a:avLst/>
+          </a:prstGeom>
+          <a:noFill/>
+          <a:ln/>
+        </p:spPr>
+        <p:txBody>
+          <a:bodyPr wrap="square" lIns="0" tIns="0" rIns="0" bIns="0" rtlCol="0" anchor="ctr"/>
+          <a:lstStyle/>
+          <a:p>
+            <a:pPr algn="r" indent="0" marL="0">
+              <a:buNone/>
+            </a:pPr>
+            <a:r>
+              <a:rPr lang="en-US" sz="1000" dirty="0">
+                <a:solidFill>
+                  <a:srgbClr val="7F7F7F"/>
+                </a:solidFill>
+                <a:latin typeface="Malgun Gothic" pitchFamily="34" charset="0"/>
+                <a:ea typeface="Malgun Gothic" pitchFamily="34" charset="-122"/>
+                <a:cs typeface="Malgun Gothic" pitchFamily="34" charset="-120"/>
+              </a:rPr>
+              <a:t>3 / 33</a:t>
+            </a:r>
+            <a:endParaRPr lang="en-US" sz="1000" dirty="0"/>
+          </a:p>
+        </p:txBody>
+      </p:sp>
+      <p:sp>
+        <p:nvSpPr>
+          <p:cNvPr id="19" name="Shape 17"/>
+          <p:cNvSpPr/>
+          <p:nvPr/>
+        </p:nvSpPr>
+        <p:spPr>
+          <a:xfrm>
+            <a:off x="320040" y="1078992"/>
+            <a:ext cx="5675224" cy="310896"/>
+          </a:xfrm>
+          <a:prstGeom prst="rect">
+            <a:avLst/>
+          </a:prstGeom>
+          <a:solidFill>
+            <a:srgbClr val="4E7C3A"/>
+          </a:solidFill>
+          <a:ln/>
+        </p:spPr>
+      </p:sp>
+      <p:sp>
+        <p:nvSpPr>
+          <p:cNvPr id="20" name="Text 18"/>
+          <p:cNvSpPr/>
+          <p:nvPr/>
+        </p:nvSpPr>
+        <p:spPr>
+          <a:xfrm>
+            <a:off x="365760" y="1078992"/>
+            <a:ext cx="5583784" cy="310896"/>
+          </a:xfrm>
+          <a:prstGeom prst="rect">
+            <a:avLst/>
+          </a:prstGeom>
+          <a:noFill/>
+          <a:ln/>
+        </p:spPr>
+        <p:txBody>
+          <a:bodyPr wrap="square" lIns="0" tIns="0" rIns="0" bIns="0" rtlCol="0" anchor="ctr"/>
+          <a:lstStyle/>
+          <a:p>
+            <a:pPr algn="ctr" indent="0" marL="0">
+              <a:buNone/>
+            </a:pPr>
+            <a:r>
+              <a:rPr lang="en-US" sz="1300" b="1" dirty="0">
+                <a:solidFill>
+                  <a:srgbClr val="FFFFFF"/>
+                </a:solidFill>
+                <a:latin typeface="Malgun Gothic" pitchFamily="34" charset="0"/>
+                <a:ea typeface="Malgun Gothic" pitchFamily="34" charset="-122"/>
+                <a:cs typeface="Malgun Gothic" pitchFamily="34" charset="-120"/>
+              </a:rPr>
+              <a:t>필요성 헤더 1</a:t>
+            </a:r>
+            <a:endParaRPr lang="en-US" sz="1300" dirty="0"/>
+          </a:p>
+        </p:txBody>
+      </p:sp>
+      <p:sp>
+        <p:nvSpPr>
+          <p:cNvPr id="21" name="Text 19"/>
+          <p:cNvSpPr/>
+          <p:nvPr/>
+        </p:nvSpPr>
+        <p:spPr>
+          <a:xfrm>
+            <a:off x="365760" y="1527048"/>
+            <a:ext cx="5583784" cy="713232"/>
+          </a:xfrm>
+          <a:prstGeom prst="rect">
+            <a:avLst/>
+          </a:prstGeom>
+          <a:noFill/>
+          <a:ln/>
+        </p:spPr>
+        <p:txBody>
+          <a:bodyPr wrap="square" lIns="0" tIns="0" rIns="0" bIns="0" rtlCol="0" anchor="t"/>
+          <a:lstStyle/>
+          <a:p>
+            <a:pPr algn="l" marL="177800" indent="-177800">
+              <a:spcAft>
+                <a:spcPts val="600"/>
+              </a:spcAft>
+              <a:buSzPct val="100000"/>
+              <a:buChar char="◆"/>
+            </a:pPr>
+            <a:r>
+              <a:rPr lang="en-US" sz="1100" dirty="0">
+                <a:solidFill>
+                  <a:srgbClr val="262626"/>
+                </a:solidFill>
+                <a:latin typeface="Malgun Gothic" pitchFamily="34" charset="0"/>
+                <a:ea typeface="Malgun Gothic" pitchFamily="34" charset="-122"/>
+                <a:cs typeface="Malgun Gothic" pitchFamily="34" charset="-120"/>
+              </a:rPr>
+              <a:t>핵심 메시지 1</a:t>
+            </a:r>
+            <a:endParaRPr lang="en-US" sz="1100" dirty="0"/>
+          </a:p>
+        </p:txBody>
+      </p:sp>
+      <p:sp>
+        <p:nvSpPr>
+          <p:cNvPr id="22" name="Shape 20"/>
+          <p:cNvSpPr/>
+          <p:nvPr/>
+        </p:nvSpPr>
+        <p:spPr>
+          <a:xfrm>
+            <a:off x="320040" y="2286000"/>
+            <a:ext cx="5675224" cy="1618488"/>
+          </a:xfrm>
+          <a:prstGeom prst="rect">
+            <a:avLst/>
+          </a:prstGeom>
+          <a:solidFill>
+            <a:srgbClr val="F5F6F8"/>
+          </a:solidFill>
+          <a:ln w="12700">
+            <a:solidFill>
+              <a:srgbClr val="A6A6A6"/>
+            </a:solidFill>
+            <a:prstDash val="solid"/>
+          </a:ln>
+        </p:spPr>
+      </p:sp>
+      <p:sp>
+        <p:nvSpPr>
+          <p:cNvPr id="23" name="Text 21"/>
+          <p:cNvSpPr/>
+          <p:nvPr/>
+        </p:nvSpPr>
+        <p:spPr>
+          <a:xfrm>
+            <a:off x="365760" y="4069080"/>
+            <a:ext cx="5583784" cy="713232"/>
+          </a:xfrm>
+          <a:prstGeom prst="rect">
+            <a:avLst/>
+          </a:prstGeom>
+          <a:noFill/>
+          <a:ln/>
+        </p:spPr>
+        <p:txBody>
+          <a:bodyPr wrap="square" lIns="0" tIns="0" rIns="0" bIns="0" rtlCol="0" anchor="t"/>
+          <a:lstStyle/>
+          <a:p>
+            <a:pPr algn="l" marL="177800" indent="-177800">
+              <a:spcAft>
+                <a:spcPts val="600"/>
+              </a:spcAft>
+              <a:buSzPct val="100000"/>
+              <a:buChar char="◆"/>
+            </a:pPr>
+            <a:r>
+              <a:rPr lang="en-US" sz="1100" dirty="0">
+                <a:solidFill>
+                  <a:srgbClr val="262626"/>
+                </a:solidFill>
+                <a:latin typeface="Malgun Gothic" pitchFamily="34" charset="0"/>
+                <a:ea typeface="Malgun Gothic" pitchFamily="34" charset="-122"/>
+                <a:cs typeface="Malgun Gothic" pitchFamily="34" charset="-120"/>
+              </a:rPr>
+              <a:t>핵심 메시지 2</a:t>
+            </a:r>
+            <a:endParaRPr lang="en-US" sz="1100" dirty="0"/>
+          </a:p>
+        </p:txBody>
+      </p:sp>
+      <p:sp>
+        <p:nvSpPr>
+          <p:cNvPr id="24" name="Shape 22"/>
+          <p:cNvSpPr/>
+          <p:nvPr/>
+        </p:nvSpPr>
+        <p:spPr>
+          <a:xfrm>
+            <a:off x="320040" y="4828032"/>
+            <a:ext cx="5675224" cy="1618488"/>
+          </a:xfrm>
+          <a:prstGeom prst="rect">
+            <a:avLst/>
+          </a:prstGeom>
+          <a:solidFill>
+            <a:srgbClr val="F5F6F8"/>
+          </a:solidFill>
+          <a:ln w="12700">
+            <a:solidFill>
+              <a:srgbClr val="A6A6A6"/>
+            </a:solidFill>
+            <a:prstDash val="solid"/>
+          </a:ln>
+        </p:spPr>
+      </p:sp>
+      <p:sp>
+        <p:nvSpPr>
+          <p:cNvPr id="25" name="Shape 23"/>
+          <p:cNvSpPr/>
+          <p:nvPr/>
+        </p:nvSpPr>
+        <p:spPr>
+          <a:xfrm>
+            <a:off x="6196432" y="1078992"/>
+            <a:ext cx="5675224" cy="310896"/>
+          </a:xfrm>
+          <a:prstGeom prst="rect">
+            <a:avLst/>
+          </a:prstGeom>
+          <a:solidFill>
+            <a:srgbClr val="4E7C3A"/>
+          </a:solidFill>
+          <a:ln/>
+        </p:spPr>
+      </p:sp>
+      <p:sp>
+        <p:nvSpPr>
+          <p:cNvPr id="26" name="Text 24"/>
+          <p:cNvSpPr/>
+          <p:nvPr/>
+        </p:nvSpPr>
+        <p:spPr>
+          <a:xfrm>
+            <a:off x="6242152" y="1078992"/>
+            <a:ext cx="5583784" cy="310896"/>
+          </a:xfrm>
+          <a:prstGeom prst="rect">
+            <a:avLst/>
+          </a:prstGeom>
+          <a:noFill/>
+          <a:ln/>
+        </p:spPr>
+        <p:txBody>
+          <a:bodyPr wrap="square" lIns="0" tIns="0" rIns="0" bIns="0" rtlCol="0" anchor="ctr"/>
+          <a:lstStyle/>
+          <a:p>
+            <a:pPr algn="ctr" indent="0" marL="0">
+              <a:buNone/>
+            </a:pPr>
+            <a:r>
+              <a:rPr lang="en-US" sz="1300" b="1" dirty="0">
+                <a:solidFill>
+                  <a:srgbClr val="FFFFFF"/>
+                </a:solidFill>
+                <a:latin typeface="Malgun Gothic" pitchFamily="34" charset="0"/>
+                <a:ea typeface="Malgun Gothic" pitchFamily="34" charset="-122"/>
+                <a:cs typeface="Malgun Gothic" pitchFamily="34" charset="-120"/>
+              </a:rPr>
+              <a:t>필요성 헤더 2</a:t>
+            </a:r>
+            <a:endParaRPr lang="en-US" sz="1300" dirty="0"/>
+          </a:p>
+        </p:txBody>
+      </p:sp>
+      <p:sp>
+        <p:nvSpPr>
+          <p:cNvPr id="27" name="Text 25"/>
+          <p:cNvSpPr/>
+          <p:nvPr/>
+        </p:nvSpPr>
+        <p:spPr>
+          <a:xfrm>
+            <a:off x="6242152" y="1527048"/>
+            <a:ext cx="5583784" cy="713232"/>
+          </a:xfrm>
+          <a:prstGeom prst="rect">
+            <a:avLst/>
+          </a:prstGeom>
+          <a:noFill/>
+          <a:ln/>
+        </p:spPr>
+        <p:txBody>
+          <a:bodyPr wrap="square" lIns="0" tIns="0" rIns="0" bIns="0" rtlCol="0" anchor="t"/>
+          <a:lstStyle/>
+          <a:p>
+            <a:pPr algn="l" marL="177800" indent="-177800">
+              <a:spcAft>
+                <a:spcPts val="600"/>
+              </a:spcAft>
+              <a:buSzPct val="100000"/>
+              <a:buChar char="◆"/>
+            </a:pPr>
+            <a:r>
+              <a:rPr lang="en-US" sz="1100" dirty="0">
+                <a:solidFill>
+                  <a:srgbClr val="262626"/>
+                </a:solidFill>
+                <a:latin typeface="Malgun Gothic" pitchFamily="34" charset="0"/>
+                <a:ea typeface="Malgun Gothic" pitchFamily="34" charset="-122"/>
+                <a:cs typeface="Malgun Gothic" pitchFamily="34" charset="-120"/>
+              </a:rPr>
+              <a:t>핵심 메시지 1</a:t>
+            </a:r>
+            <a:endParaRPr lang="en-US" sz="1100" dirty="0"/>
+          </a:p>
+        </p:txBody>
+      </p:sp>
+      <p:sp>
+        <p:nvSpPr>
+          <p:cNvPr id="28" name="Shape 26"/>
+          <p:cNvSpPr/>
+          <p:nvPr/>
+        </p:nvSpPr>
+        <p:spPr>
+          <a:xfrm>
+            <a:off x="6196432" y="2286000"/>
+            <a:ext cx="5675224" cy="1618488"/>
+          </a:xfrm>
+          <a:prstGeom prst="rect">
+            <a:avLst/>
+          </a:prstGeom>
+          <a:solidFill>
+            <a:srgbClr val="F5F6F8"/>
+          </a:solidFill>
+          <a:ln w="12700">
+            <a:solidFill>
+              <a:srgbClr val="A6A6A6"/>
+            </a:solidFill>
+            <a:prstDash val="solid"/>
+          </a:ln>
+        </p:spPr>
+      </p:sp>
+      <p:sp>
+        <p:nvSpPr>
+          <p:cNvPr id="29" name="Text 27"/>
+          <p:cNvSpPr/>
+          <p:nvPr/>
+        </p:nvSpPr>
+        <p:spPr>
+          <a:xfrm>
+            <a:off x="6242152" y="4069080"/>
+            <a:ext cx="5583784" cy="713232"/>
+          </a:xfrm>
+          <a:prstGeom prst="rect">
+            <a:avLst/>
+          </a:prstGeom>
+          <a:noFill/>
+          <a:ln/>
+        </p:spPr>
+        <p:txBody>
+          <a:bodyPr wrap="square" lIns="0" tIns="0" rIns="0" bIns="0" rtlCol="0" anchor="t"/>
+          <a:lstStyle/>
+          <a:p>
+            <a:pPr algn="l" marL="177800" indent="-177800">
+              <a:spcAft>
+                <a:spcPts val="600"/>
+              </a:spcAft>
+              <a:buSzPct val="100000"/>
+              <a:buChar char="◆"/>
+            </a:pPr>
+            <a:r>
+              <a:rPr lang="en-US" sz="1100" dirty="0">
+                <a:solidFill>
+                  <a:srgbClr val="262626"/>
+                </a:solidFill>
+                <a:latin typeface="Malgun Gothic" pitchFamily="34" charset="0"/>
+                <a:ea typeface="Malgun Gothic" pitchFamily="34" charset="-122"/>
+                <a:cs typeface="Malgun Gothic" pitchFamily="34" charset="-120"/>
+              </a:rPr>
+              <a:t>핵심 메시지 2</a:t>
+            </a:r>
+            <a:endParaRPr lang="en-US" sz="1100" dirty="0"/>
+          </a:p>
+        </p:txBody>
+      </p:sp>
+      <p:sp>
+        <p:nvSpPr>
+          <p:cNvPr id="30" name="Shape 28"/>
+          <p:cNvSpPr/>
+          <p:nvPr/>
+        </p:nvSpPr>
+        <p:spPr>
+          <a:xfrm>
+            <a:off x="6196432" y="4828032"/>
+            <a:ext cx="5675224" cy="1618488"/>
+          </a:xfrm>
+          <a:prstGeom prst="rect">
+            <a:avLst/>
+          </a:prstGeom>
+          <a:solidFill>
+            <a:srgbClr val="F5F6F8"/>
+          </a:solidFill>
+          <a:ln w="12700">
+            <a:solidFill>
+              <a:srgbClr val="A6A6A6"/>
+            </a:solidFill>
+            <a:prstDash val="solid"/>
+          </a:ln>
+        </p:spPr>
+      </p:sp>
+    </p:spTree>
+  </p:cSld>
+  <p:clrMapOvr>
+    <a:masterClrMapping/>
+  </p:clrMapOvr>
+</p:sld>
+</file>
+
+<file path=ppt/slides/slide4.xml><?xml version="1.0" encoding="utf-8"?>
+<p:sld xmlns:a="http://schemas.openxmlformats.org/drawingml/2006/main" xmlns:r="http://schemas.openxmlformats.org/officeDocument/2006/relationships" xmlns:p="http://schemas.openxmlformats.org/presentationml/2006/main">
+  <p:cSld name="Slide 4">
+    <p:spTree>
+      <p:nvGrpSpPr>
+        <p:cNvPr id="1" name=""/>
+        <p:cNvGrpSpPr/>
+        <p:nvPr/>
+      </p:nvGrpSpPr>
+      <p:grpSpPr>
+        <a:xfrm>
+          <a:off x="0" y="0"/>
+          <a:ext cx="0" cy="0"/>
+          <a:chOff x="0" y="0"/>
+          <a:chExt cx="0" cy="0"/>
+        </a:xfrm>
+      </p:grpSpPr>
+      <p:sp>
+        <p:nvSpPr>
+          <p:cNvPr id="2" name="Shape 0"/>
+          <p:cNvSpPr/>
+          <p:nvPr/>
+        </p:nvSpPr>
+        <p:spPr>
+          <a:xfrm>
+            <a:off x="0" y="0"/>
+            <a:ext cx="12191695" cy="914400"/>
           </a:xfrm>
           <a:prstGeom prst="rect">
             <a:avLst/>
@@ -3981,7 +4481,7 @@
         </p:nvSpPr>
         <p:spPr>
           <a:xfrm>
-            <a:off x="4160520" y="320040"/>
+            <a:off x="7208215" y="320040"/>
             <a:ext cx="786384" cy="274320"/>
           </a:xfrm>
           <a:prstGeom prst="rect">
@@ -4006,7 +4506,7 @@
         </p:nvSpPr>
         <p:spPr>
           <a:xfrm>
-            <a:off x="4160520" y="320040"/>
+            <a:off x="7208215" y="320040"/>
             <a:ext cx="786384" cy="274320"/>
           </a:xfrm>
           <a:prstGeom prst="rect">
@@ -4045,7 +4545,7 @@
         </p:nvSpPr>
         <p:spPr>
           <a:xfrm>
-            <a:off x="4960620" y="338328"/>
+            <a:off x="8008315" y="338328"/>
             <a:ext cx="155448" cy="237744"/>
           </a:xfrm>
           <a:prstGeom prst="chevron">
@@ -4065,7 +4565,7 @@
         </p:nvSpPr>
         <p:spPr>
           <a:xfrm>
-            <a:off x="5129784" y="320040"/>
+            <a:off x="8177479" y="320040"/>
             <a:ext cx="786384" cy="274320"/>
           </a:xfrm>
           <a:prstGeom prst="rect">
@@ -4090,7 +4590,7 @@
         </p:nvSpPr>
         <p:spPr>
           <a:xfrm>
-            <a:off x="5129784" y="320040"/>
+            <a:off x="8177479" y="320040"/>
             <a:ext cx="786384" cy="274320"/>
           </a:xfrm>
           <a:prstGeom prst="rect">
@@ -4129,7 +4629,7 @@
         </p:nvSpPr>
         <p:spPr>
           <a:xfrm>
-            <a:off x="5929884" y="338328"/>
+            <a:off x="8977579" y="338328"/>
             <a:ext cx="155448" cy="237744"/>
           </a:xfrm>
           <a:prstGeom prst="chevron">
@@ -4149,7 +4649,7 @@
         </p:nvSpPr>
         <p:spPr>
           <a:xfrm>
-            <a:off x="6099048" y="320040"/>
+            <a:off x="9146743" y="320040"/>
             <a:ext cx="786384" cy="274320"/>
           </a:xfrm>
           <a:prstGeom prst="rect">
@@ -4174,7 +4674,7 @@
         </p:nvSpPr>
         <p:spPr>
           <a:xfrm>
-            <a:off x="6099048" y="320040"/>
+            <a:off x="9146743" y="320040"/>
             <a:ext cx="786384" cy="274320"/>
           </a:xfrm>
           <a:prstGeom prst="rect">
@@ -4213,7 +4713,7 @@
         </p:nvSpPr>
         <p:spPr>
           <a:xfrm>
-            <a:off x="6899148" y="338328"/>
+            <a:off x="9946843" y="338328"/>
             <a:ext cx="155448" cy="237744"/>
           </a:xfrm>
           <a:prstGeom prst="chevron">
@@ -4233,7 +4733,7 @@
         </p:nvSpPr>
         <p:spPr>
           <a:xfrm>
-            <a:off x="7068312" y="320040"/>
+            <a:off x="10116007" y="320040"/>
             <a:ext cx="786384" cy="274320"/>
           </a:xfrm>
           <a:prstGeom prst="rect">
@@ -4258,7 +4758,7 @@
         </p:nvSpPr>
         <p:spPr>
           <a:xfrm>
-            <a:off x="7068312" y="320040"/>
+            <a:off x="10116007" y="320040"/>
             <a:ext cx="786384" cy="274320"/>
           </a:xfrm>
           <a:prstGeom prst="rect">
@@ -4297,7 +4797,7 @@
         </p:nvSpPr>
         <p:spPr>
           <a:xfrm>
-            <a:off x="7868412" y="338328"/>
+            <a:off x="10916107" y="338328"/>
             <a:ext cx="155448" cy="237744"/>
           </a:xfrm>
           <a:prstGeom prst="chevron">
@@ -4317,7 +4817,7 @@
         </p:nvSpPr>
         <p:spPr>
           <a:xfrm>
-            <a:off x="8037576" y="320040"/>
+            <a:off x="11085271" y="320040"/>
             <a:ext cx="786384" cy="274320"/>
           </a:xfrm>
           <a:prstGeom prst="rect">
@@ -4342,7 +4842,7 @@
         </p:nvSpPr>
         <p:spPr>
           <a:xfrm>
-            <a:off x="8037576" y="320040"/>
+            <a:off x="11085271" y="320040"/>
             <a:ext cx="786384" cy="274320"/>
           </a:xfrm>
           <a:prstGeom prst="rect">
@@ -4381,7 +4881,7 @@
         </p:nvSpPr>
         <p:spPr>
           <a:xfrm>
-            <a:off x="7680960" y="6492240"/>
+            <a:off x="10728655" y="6492240"/>
             <a:ext cx="1280160" cy="256032"/>
           </a:xfrm>
           <a:prstGeom prst="rect">
@@ -4406,7 +4906,7 @@
                 <a:ea typeface="Malgun Gothic" pitchFamily="34" charset="-122"/>
                 <a:cs typeface="Malgun Gothic" pitchFamily="34" charset="-120"/>
               </a:rPr>
-              <a:t>3 / 33</a:t>
+              <a:t>4 / 33</a:t>
             </a:r>
             <a:endParaRPr lang="en-US" sz="1000" dirty="0"/>
           </a:p>
@@ -4421,7 +4921,7 @@
         <p:spPr>
           <a:xfrm>
             <a:off x="320040" y="1078992"/>
-            <a:ext cx="2700528" cy="310896"/>
+            <a:ext cx="3716426" cy="310896"/>
           </a:xfrm>
           <a:prstGeom prst="rect">
             <a:avLst/>
@@ -4441,7 +4941,7 @@
         <p:spPr>
           <a:xfrm>
             <a:off x="365760" y="1078992"/>
-            <a:ext cx="2609088" cy="310896"/>
+            <a:ext cx="3624986" cy="310896"/>
           </a:xfrm>
           <a:prstGeom prst="rect">
             <a:avLst/>
@@ -4473,39 +4973,14 @@
       </p:sp>
       <p:sp>
         <p:nvSpPr>
-          <p:cNvPr id="21" name="Shape 19"/>
-          <p:cNvSpPr/>
-          <p:nvPr/>
-        </p:nvSpPr>
-        <p:spPr>
-          <a:xfrm>
-            <a:off x="320040" y="1490472"/>
-            <a:ext cx="2700528" cy="3977640"/>
-          </a:xfrm>
-          <a:prstGeom prst="rect">
-            <a:avLst/>
-          </a:prstGeom>
-          <a:solidFill>
-            <a:srgbClr val="F5F6F8"/>
-          </a:solidFill>
-          <a:ln w="12700">
-            <a:solidFill>
-              <a:srgbClr val="A6A6A6"/>
-            </a:solidFill>
-            <a:prstDash val="dash"/>
-          </a:ln>
-        </p:spPr>
-      </p:sp>
-      <p:sp>
-        <p:nvSpPr>
-          <p:cNvPr id="22" name="Text 20"/>
-          <p:cNvSpPr/>
-          <p:nvPr/>
-        </p:nvSpPr>
-        <p:spPr>
-          <a:xfrm>
-            <a:off x="320040" y="1490472"/>
-            <a:ext cx="2700528" cy="3977640"/>
+          <p:cNvPr id="21" name="Text 19"/>
+          <p:cNvSpPr/>
+          <p:nvPr/>
+        </p:nvSpPr>
+        <p:spPr>
+          <a:xfrm>
+            <a:off x="365760" y="1527048"/>
+            <a:ext cx="3624986" cy="713232"/>
           </a:xfrm>
           <a:prstGeom prst="rect">
             <a:avLst/>
@@ -4514,22 +4989,26 @@
           <a:ln/>
         </p:spPr>
         <p:txBody>
-          <a:bodyPr wrap="square" rtlCol="0" anchor="ctr"/>
-          <a:lstStyle/>
-          <a:p>
-            <a:pPr algn="ctr" indent="0" marL="0">
-              <a:buNone/>
+          <a:bodyPr wrap="square" lIns="0" tIns="0" rIns="0" bIns="0" rtlCol="0" anchor="t"/>
+          <a:lstStyle/>
+          <a:p>
+            <a:pPr algn="l" marL="177800" indent="-177800">
+              <a:spcAft>
+                <a:spcPts val="600"/>
+              </a:spcAft>
+              <a:buSzPct val="100000"/>
+              <a:buChar char="◆"/>
             </a:pPr>
             <a:r>
               <a:rPr lang="en-US" sz="1100" dirty="0">
                 <a:solidFill>
-                  <a:srgbClr val="9AA0A6"/>
+                  <a:srgbClr val="262626"/>
                 </a:solidFill>
                 <a:latin typeface="Malgun Gothic" pitchFamily="34" charset="0"/>
                 <a:ea typeface="Malgun Gothic" pitchFamily="34" charset="-122"/>
                 <a:cs typeface="Malgun Gothic" pitchFamily="34" charset="-120"/>
               </a:rPr>
-              <a:t>[ 이미지 / 다이어그램 ]</a:t>
+              <a:t>범위 항목 1</a:t>
             </a:r>
             <a:endParaRPr lang="en-US" sz="1100" dirty="0"/>
           </a:p>
@@ -4537,14 +5016,107 @@
       </p:sp>
       <p:sp>
         <p:nvSpPr>
-          <p:cNvPr id="23" name="Shape 21"/>
-          <p:cNvSpPr/>
-          <p:nvPr/>
-        </p:nvSpPr>
-        <p:spPr>
-          <a:xfrm>
-            <a:off x="3221736" y="1078992"/>
-            <a:ext cx="2700528" cy="310896"/>
+          <p:cNvPr id="22" name="Shape 20"/>
+          <p:cNvSpPr/>
+          <p:nvPr/>
+        </p:nvSpPr>
+        <p:spPr>
+          <a:xfrm>
+            <a:off x="320040" y="2286000"/>
+            <a:ext cx="3716426" cy="1618488"/>
+          </a:xfrm>
+          <a:prstGeom prst="rect">
+            <a:avLst/>
+          </a:prstGeom>
+          <a:solidFill>
+            <a:srgbClr val="F5F6F8"/>
+          </a:solidFill>
+          <a:ln w="12700">
+            <a:solidFill>
+              <a:srgbClr val="A6A6A6"/>
+            </a:solidFill>
+            <a:prstDash val="solid"/>
+          </a:ln>
+        </p:spPr>
+      </p:sp>
+      <p:sp>
+        <p:nvSpPr>
+          <p:cNvPr id="23" name="Text 21"/>
+          <p:cNvSpPr/>
+          <p:nvPr/>
+        </p:nvSpPr>
+        <p:spPr>
+          <a:xfrm>
+            <a:off x="365760" y="4069080"/>
+            <a:ext cx="3624986" cy="713232"/>
+          </a:xfrm>
+          <a:prstGeom prst="rect">
+            <a:avLst/>
+          </a:prstGeom>
+          <a:noFill/>
+          <a:ln/>
+        </p:spPr>
+        <p:txBody>
+          <a:bodyPr wrap="square" lIns="0" tIns="0" rIns="0" bIns="0" rtlCol="0" anchor="t"/>
+          <a:lstStyle/>
+          <a:p>
+            <a:pPr algn="l" marL="177800" indent="-177800">
+              <a:spcAft>
+                <a:spcPts val="600"/>
+              </a:spcAft>
+              <a:buSzPct val="100000"/>
+              <a:buChar char="◆"/>
+            </a:pPr>
+            <a:r>
+              <a:rPr lang="en-US" sz="1100" dirty="0">
+                <a:solidFill>
+                  <a:srgbClr val="262626"/>
+                </a:solidFill>
+                <a:latin typeface="Malgun Gothic" pitchFamily="34" charset="0"/>
+                <a:ea typeface="Malgun Gothic" pitchFamily="34" charset="-122"/>
+                <a:cs typeface="Malgun Gothic" pitchFamily="34" charset="-120"/>
+              </a:rPr>
+              <a:t>범위 항목 2</a:t>
+            </a:r>
+            <a:endParaRPr lang="en-US" sz="1100" dirty="0"/>
+          </a:p>
+        </p:txBody>
+      </p:sp>
+      <p:sp>
+        <p:nvSpPr>
+          <p:cNvPr id="24" name="Shape 22"/>
+          <p:cNvSpPr/>
+          <p:nvPr/>
+        </p:nvSpPr>
+        <p:spPr>
+          <a:xfrm>
+            <a:off x="320040" y="4828032"/>
+            <a:ext cx="3716426" cy="1618488"/>
+          </a:xfrm>
+          <a:prstGeom prst="rect">
+            <a:avLst/>
+          </a:prstGeom>
+          <a:solidFill>
+            <a:srgbClr val="F5F6F8"/>
+          </a:solidFill>
+          <a:ln w="12700">
+            <a:solidFill>
+              <a:srgbClr val="A6A6A6"/>
+            </a:solidFill>
+            <a:prstDash val="solid"/>
+          </a:ln>
+        </p:spPr>
+      </p:sp>
+      <p:sp>
+        <p:nvSpPr>
+          <p:cNvPr id="25" name="Shape 23"/>
+          <p:cNvSpPr/>
+          <p:nvPr/>
+        </p:nvSpPr>
+        <p:spPr>
+          <a:xfrm>
+            <a:off x="4237634" y="1078992"/>
+            <a:ext cx="3716426" cy="310896"/>
           </a:xfrm>
           <a:prstGeom prst="rect">
             <a:avLst/>
@@ -4557,14 +5129,14 @@
       </p:sp>
       <p:sp>
         <p:nvSpPr>
-          <p:cNvPr id="24" name="Text 22"/>
-          <p:cNvSpPr/>
-          <p:nvPr/>
-        </p:nvSpPr>
-        <p:spPr>
-          <a:xfrm>
-            <a:off x="3267456" y="1078992"/>
-            <a:ext cx="2609088" cy="310896"/>
+          <p:cNvPr id="26" name="Text 24"/>
+          <p:cNvSpPr/>
+          <p:nvPr/>
+        </p:nvSpPr>
+        <p:spPr>
+          <a:xfrm>
+            <a:off x="4283354" y="1078992"/>
+            <a:ext cx="3624986" cy="310896"/>
           </a:xfrm>
           <a:prstGeom prst="rect">
             <a:avLst/>
@@ -4596,39 +5168,14 @@
       </p:sp>
       <p:sp>
         <p:nvSpPr>
-          <p:cNvPr id="25" name="Shape 23"/>
-          <p:cNvSpPr/>
-          <p:nvPr/>
-        </p:nvSpPr>
-        <p:spPr>
-          <a:xfrm>
-            <a:off x="3221736" y="1490472"/>
-            <a:ext cx="2700528" cy="3977640"/>
-          </a:xfrm>
-          <a:prstGeom prst="rect">
-            <a:avLst/>
-          </a:prstGeom>
-          <a:solidFill>
-            <a:srgbClr val="F5F6F8"/>
-          </a:solidFill>
-          <a:ln w="12700">
-            <a:solidFill>
-              <a:srgbClr val="A6A6A6"/>
-            </a:solidFill>
-            <a:prstDash val="dash"/>
-          </a:ln>
-        </p:spPr>
-      </p:sp>
-      <p:sp>
-        <p:nvSpPr>
-          <p:cNvPr id="26" name="Text 24"/>
-          <p:cNvSpPr/>
-          <p:nvPr/>
-        </p:nvSpPr>
-        <p:spPr>
-          <a:xfrm>
-            <a:off x="3221736" y="1490472"/>
-            <a:ext cx="2700528" cy="3977640"/>
+          <p:cNvPr id="27" name="Text 25"/>
+          <p:cNvSpPr/>
+          <p:nvPr/>
+        </p:nvSpPr>
+        <p:spPr>
+          <a:xfrm>
+            <a:off x="4283354" y="1527048"/>
+            <a:ext cx="3624986" cy="713232"/>
           </a:xfrm>
           <a:prstGeom prst="rect">
             <a:avLst/>
@@ -4637,22 +5184,26 @@
           <a:ln/>
         </p:spPr>
         <p:txBody>
-          <a:bodyPr wrap="square" rtlCol="0" anchor="ctr"/>
-          <a:lstStyle/>
-          <a:p>
-            <a:pPr algn="ctr" indent="0" marL="0">
-              <a:buNone/>
+          <a:bodyPr wrap="square" lIns="0" tIns="0" rIns="0" bIns="0" rtlCol="0" anchor="t"/>
+          <a:lstStyle/>
+          <a:p>
+            <a:pPr algn="l" marL="177800" indent="-177800">
+              <a:spcAft>
+                <a:spcPts val="600"/>
+              </a:spcAft>
+              <a:buSzPct val="100000"/>
+              <a:buChar char="◆"/>
             </a:pPr>
             <a:r>
               <a:rPr lang="en-US" sz="1100" dirty="0">
                 <a:solidFill>
-                  <a:srgbClr val="9AA0A6"/>
+                  <a:srgbClr val="262626"/>
                 </a:solidFill>
                 <a:latin typeface="Malgun Gothic" pitchFamily="34" charset="0"/>
                 <a:ea typeface="Malgun Gothic" pitchFamily="34" charset="-122"/>
                 <a:cs typeface="Malgun Gothic" pitchFamily="34" charset="-120"/>
               </a:rPr>
-              <a:t>[ 이미지 / 다이어그램 ]</a:t>
+              <a:t>범위 항목 1</a:t>
             </a:r>
             <a:endParaRPr lang="en-US" sz="1100" dirty="0"/>
           </a:p>
@@ -4660,14 +5211,107 @@
       </p:sp>
       <p:sp>
         <p:nvSpPr>
-          <p:cNvPr id="27" name="Shape 25"/>
-          <p:cNvSpPr/>
-          <p:nvPr/>
-        </p:nvSpPr>
-        <p:spPr>
-          <a:xfrm>
-            <a:off x="6123432" y="1078992"/>
-            <a:ext cx="2700528" cy="310896"/>
+          <p:cNvPr id="28" name="Shape 26"/>
+          <p:cNvSpPr/>
+          <p:nvPr/>
+        </p:nvSpPr>
+        <p:spPr>
+          <a:xfrm>
+            <a:off x="4237634" y="2286000"/>
+            <a:ext cx="3716426" cy="1618488"/>
+          </a:xfrm>
+          <a:prstGeom prst="rect">
+            <a:avLst/>
+          </a:prstGeom>
+          <a:solidFill>
+            <a:srgbClr val="F5F6F8"/>
+          </a:solidFill>
+          <a:ln w="12700">
+            <a:solidFill>
+              <a:srgbClr val="A6A6A6"/>
+            </a:solidFill>
+            <a:prstDash val="solid"/>
+          </a:ln>
+        </p:spPr>
+      </p:sp>
+      <p:sp>
+        <p:nvSpPr>
+          <p:cNvPr id="29" name="Text 27"/>
+          <p:cNvSpPr/>
+          <p:nvPr/>
+        </p:nvSpPr>
+        <p:spPr>
+          <a:xfrm>
+            <a:off x="4283354" y="4069080"/>
+            <a:ext cx="3624986" cy="713232"/>
+          </a:xfrm>
+          <a:prstGeom prst="rect">
+            <a:avLst/>
+          </a:prstGeom>
+          <a:noFill/>
+          <a:ln/>
+        </p:spPr>
+        <p:txBody>
+          <a:bodyPr wrap="square" lIns="0" tIns="0" rIns="0" bIns="0" rtlCol="0" anchor="t"/>
+          <a:lstStyle/>
+          <a:p>
+            <a:pPr algn="l" marL="177800" indent="-177800">
+              <a:spcAft>
+                <a:spcPts val="600"/>
+              </a:spcAft>
+              <a:buSzPct val="100000"/>
+              <a:buChar char="◆"/>
+            </a:pPr>
+            <a:r>
+              <a:rPr lang="en-US" sz="1100" dirty="0">
+                <a:solidFill>
+                  <a:srgbClr val="262626"/>
+                </a:solidFill>
+                <a:latin typeface="Malgun Gothic" pitchFamily="34" charset="0"/>
+                <a:ea typeface="Malgun Gothic" pitchFamily="34" charset="-122"/>
+                <a:cs typeface="Malgun Gothic" pitchFamily="34" charset="-120"/>
+              </a:rPr>
+              <a:t>범위 항목 2</a:t>
+            </a:r>
+            <a:endParaRPr lang="en-US" sz="1100" dirty="0"/>
+          </a:p>
+        </p:txBody>
+      </p:sp>
+      <p:sp>
+        <p:nvSpPr>
+          <p:cNvPr id="30" name="Shape 28"/>
+          <p:cNvSpPr/>
+          <p:nvPr/>
+        </p:nvSpPr>
+        <p:spPr>
+          <a:xfrm>
+            <a:off x="4237634" y="4828032"/>
+            <a:ext cx="3716426" cy="1618488"/>
+          </a:xfrm>
+          <a:prstGeom prst="rect">
+            <a:avLst/>
+          </a:prstGeom>
+          <a:solidFill>
+            <a:srgbClr val="F5F6F8"/>
+          </a:solidFill>
+          <a:ln w="12700">
+            <a:solidFill>
+              <a:srgbClr val="A6A6A6"/>
+            </a:solidFill>
+            <a:prstDash val="solid"/>
+          </a:ln>
+        </p:spPr>
+      </p:sp>
+      <p:sp>
+        <p:nvSpPr>
+          <p:cNvPr id="31" name="Shape 29"/>
+          <p:cNvSpPr/>
+          <p:nvPr/>
+        </p:nvSpPr>
+        <p:spPr>
+          <a:xfrm>
+            <a:off x="8155229" y="1078992"/>
+            <a:ext cx="3716426" cy="310896"/>
           </a:xfrm>
           <a:prstGeom prst="rect">
             <a:avLst/>
@@ -4680,14 +5324,14 @@
       </p:sp>
       <p:sp>
         <p:nvSpPr>
-          <p:cNvPr id="28" name="Text 26"/>
-          <p:cNvSpPr/>
-          <p:nvPr/>
-        </p:nvSpPr>
-        <p:spPr>
-          <a:xfrm>
-            <a:off x="6169152" y="1078992"/>
-            <a:ext cx="2609088" cy="310896"/>
+          <p:cNvPr id="32" name="Text 30"/>
+          <p:cNvSpPr/>
+          <p:nvPr/>
+        </p:nvSpPr>
+        <p:spPr>
+          <a:xfrm>
+            <a:off x="8200949" y="1078992"/>
+            <a:ext cx="3624986" cy="310896"/>
           </a:xfrm>
           <a:prstGeom prst="rect">
             <a:avLst/>
@@ -4719,14 +5363,14 @@
       </p:sp>
       <p:sp>
         <p:nvSpPr>
-          <p:cNvPr id="29" name="Text 27"/>
-          <p:cNvSpPr/>
-          <p:nvPr/>
-        </p:nvSpPr>
-        <p:spPr>
-          <a:xfrm>
-            <a:off x="6123432" y="1901952"/>
-            <a:ext cx="2700528" cy="640080"/>
+          <p:cNvPr id="33" name="Text 31"/>
+          <p:cNvSpPr/>
+          <p:nvPr/>
+        </p:nvSpPr>
+        <p:spPr>
+          <a:xfrm>
+            <a:off x="8200949" y="1527048"/>
+            <a:ext cx="3624986" cy="713232"/>
           </a:xfrm>
           <a:prstGeom prst="rect">
             <a:avLst/>
@@ -4735,50 +5379,15 @@
           <a:ln/>
         </p:spPr>
         <p:txBody>
-          <a:bodyPr wrap="square" lIns="0" tIns="0" rIns="0" bIns="0" rtlCol="0" anchor="ctr"/>
-          <a:lstStyle/>
-          <a:p>
-            <a:pPr algn="ctr" indent="0" marL="0">
-              <a:buNone/>
-            </a:pPr>
-            <a:r>
-              <a:rPr lang="en-US" sz="4000" b="1" dirty="0">
-                <a:solidFill>
-                  <a:srgbClr val="1F3864"/>
-                </a:solidFill>
-                <a:latin typeface="Malgun Gothic" pitchFamily="34" charset="0"/>
-                <a:ea typeface="Malgun Gothic" pitchFamily="34" charset="-122"/>
-                <a:cs typeface="Malgun Gothic" pitchFamily="34" charset="-120"/>
-              </a:rPr>
-              <a:t>3</a:t>
-            </a:r>
-            <a:endParaRPr lang="en-US" sz="4000" dirty="0"/>
-          </a:p>
-        </p:txBody>
-      </p:sp>
-      <p:sp>
-        <p:nvSpPr>
-          <p:cNvPr id="30" name="Text 28"/>
-          <p:cNvSpPr/>
-          <p:nvPr/>
-        </p:nvSpPr>
-        <p:spPr>
-          <a:xfrm>
-            <a:off x="6123432" y="2542032"/>
-            <a:ext cx="2700528" cy="274320"/>
-          </a:xfrm>
-          <a:prstGeom prst="rect">
-            <a:avLst/>
-          </a:prstGeom>
-          <a:noFill/>
-          <a:ln/>
-        </p:spPr>
-        <p:txBody>
           <a:bodyPr wrap="square" lIns="0" tIns="0" rIns="0" bIns="0" rtlCol="0" anchor="t"/>
           <a:lstStyle/>
           <a:p>
-            <a:pPr algn="ctr" indent="0" marL="0">
-              <a:buNone/>
+            <a:pPr algn="l" marL="177800" indent="-177800">
+              <a:spcAft>
+                <a:spcPts val="600"/>
+              </a:spcAft>
+              <a:buSzPct val="100000"/>
+              <a:buChar char="◆"/>
             </a:pPr>
             <a:r>
               <a:rPr lang="en-US" sz="1100" dirty="0">
@@ -4789,7 +5398,7 @@
                 <a:ea typeface="Malgun Gothic" pitchFamily="34" charset="-122"/>
                 <a:cs typeface="Malgun Gothic" pitchFamily="34" charset="-120"/>
               </a:rPr>
-              <a:t>타겟 하드웨어</a:t>
+              <a:t>범위 항목 1</a:t>
             </a:r>
             <a:endParaRPr lang="en-US" sz="1100" dirty="0"/>
           </a:p>
@@ -4797,14 +5406,39 @@
       </p:sp>
       <p:sp>
         <p:nvSpPr>
-          <p:cNvPr id="31" name="Text 29"/>
-          <p:cNvSpPr/>
-          <p:nvPr/>
-        </p:nvSpPr>
-        <p:spPr>
-          <a:xfrm>
-            <a:off x="6123432" y="3456432"/>
-            <a:ext cx="2700528" cy="640080"/>
+          <p:cNvPr id="34" name="Shape 32"/>
+          <p:cNvSpPr/>
+          <p:nvPr/>
+        </p:nvSpPr>
+        <p:spPr>
+          <a:xfrm>
+            <a:off x="8155229" y="2286000"/>
+            <a:ext cx="3716426" cy="1618488"/>
+          </a:xfrm>
+          <a:prstGeom prst="rect">
+            <a:avLst/>
+          </a:prstGeom>
+          <a:solidFill>
+            <a:srgbClr val="F5F6F8"/>
+          </a:solidFill>
+          <a:ln w="12700">
+            <a:solidFill>
+              <a:srgbClr val="A6A6A6"/>
+            </a:solidFill>
+            <a:prstDash val="solid"/>
+          </a:ln>
+        </p:spPr>
+      </p:sp>
+      <p:sp>
+        <p:nvSpPr>
+          <p:cNvPr id="35" name="Text 33"/>
+          <p:cNvSpPr/>
+          <p:nvPr/>
+        </p:nvSpPr>
+        <p:spPr>
+          <a:xfrm>
+            <a:off x="8200949" y="4069080"/>
+            <a:ext cx="3624986" cy="713232"/>
           </a:xfrm>
           <a:prstGeom prst="rect">
             <a:avLst/>
@@ -4813,50 +5447,15 @@
           <a:ln/>
         </p:spPr>
         <p:txBody>
-          <a:bodyPr wrap="square" lIns="0" tIns="0" rIns="0" bIns="0" rtlCol="0" anchor="ctr"/>
-          <a:lstStyle/>
-          <a:p>
-            <a:pPr algn="ctr" indent="0" marL="0">
-              <a:buNone/>
-            </a:pPr>
-            <a:r>
-              <a:rPr lang="en-US" sz="4000" b="1" dirty="0">
-                <a:solidFill>
-                  <a:srgbClr val="4E7C3A"/>
-                </a:solidFill>
-                <a:latin typeface="Malgun Gothic" pitchFamily="34" charset="0"/>
-                <a:ea typeface="Malgun Gothic" pitchFamily="34" charset="-122"/>
-                <a:cs typeface="Malgun Gothic" pitchFamily="34" charset="-120"/>
-              </a:rPr>
-              <a:t>10</a:t>
-            </a:r>
-            <a:endParaRPr lang="en-US" sz="4000" dirty="0"/>
-          </a:p>
-        </p:txBody>
-      </p:sp>
-      <p:sp>
-        <p:nvSpPr>
-          <p:cNvPr id="32" name="Text 30"/>
-          <p:cNvSpPr/>
-          <p:nvPr/>
-        </p:nvSpPr>
-        <p:spPr>
-          <a:xfrm>
-            <a:off x="6123432" y="4096512"/>
-            <a:ext cx="2700528" cy="274320"/>
-          </a:xfrm>
-          <a:prstGeom prst="rect">
-            <a:avLst/>
-          </a:prstGeom>
-          <a:noFill/>
-          <a:ln/>
-        </p:spPr>
-        <p:txBody>
           <a:bodyPr wrap="square" lIns="0" tIns="0" rIns="0" bIns="0" rtlCol="0" anchor="t"/>
           <a:lstStyle/>
           <a:p>
-            <a:pPr algn="ctr" indent="0" marL="0">
-              <a:buNone/>
+            <a:pPr algn="l" marL="177800" indent="-177800">
+              <a:spcAft>
+                <a:spcPts val="600"/>
+              </a:spcAft>
+              <a:buSzPct val="100000"/>
+              <a:buChar char="◆"/>
             </a:pPr>
             <a:r>
               <a:rPr lang="en-US" sz="1100" dirty="0">
@@ -4867,11 +5466,36 @@
                 <a:ea typeface="Malgun Gothic" pitchFamily="34" charset="-122"/>
                 <a:cs typeface="Malgun Gothic" pitchFamily="34" charset="-120"/>
               </a:rPr>
-              <a:t>개월 개발 기간</a:t>
+              <a:t>범위 항목 2</a:t>
             </a:r>
             <a:endParaRPr lang="en-US" sz="1100" dirty="0"/>
           </a:p>
         </p:txBody>
+      </p:sp>
+      <p:sp>
+        <p:nvSpPr>
+          <p:cNvPr id="36" name="Shape 34"/>
+          <p:cNvSpPr/>
+          <p:nvPr/>
+        </p:nvSpPr>
+        <p:spPr>
+          <a:xfrm>
+            <a:off x="8155229" y="4828032"/>
+            <a:ext cx="3716426" cy="1618488"/>
+          </a:xfrm>
+          <a:prstGeom prst="rect">
+            <a:avLst/>
+          </a:prstGeom>
+          <a:solidFill>
+            <a:srgbClr val="F5F6F8"/>
+          </a:solidFill>
+          <a:ln w="12700">
+            <a:solidFill>
+              <a:srgbClr val="A6A6A6"/>
+            </a:solidFill>
+            <a:prstDash val="solid"/>
+          </a:ln>
+        </p:spPr>
       </p:sp>
     </p:spTree>
   </p:cSld>

</xml_diff>